<commit_message>
docs(slides): use gateway URLs, add speaker photos and architecture diagram (#11)
</commit_message>
<xml_diff>
--- a/slides/agentic-idp-workshop.pptx
+++ b/slides/agentic-idp-workshop.pptx
@@ -58,6 +58,7 @@
     <p:sldId id="356" r:id="rId92"/>
     <p:sldId id="357" r:id="rId93"/>
     <p:sldId id="358" r:id="rId94"/>
+    <p:sldId id="359" r:id="rId95"/>
   </p:sldIdLst>
   <p:sldSz cx="18288000" cy="10287000"/>
   <p:notesSz cx="6858000" cy="9144000"/>
@@ -4571,9 +4572,12 @@
                 </a:path>
               </a:pathLst>
             </a:custGeom>
-            <a:solidFill>
-              <a:srgbClr val="FFFFFF"/>
-            </a:solidFill>
+            <a:blipFill>
+              <a:blip r:embed="rId5"/>
+              <a:stretch>
+                <a:fillRect/>
+              </a:stretch>
+            </a:blipFill>
           </p:spPr>
           <p:txBody>
             <a:bodyPr/>
@@ -4812,7 +4816,7 @@
         <p:spPr>
           <a:xfrm>
             <a:off x="8641280" y="3521284"/>
-            <a:ext cx="8618019" cy="4422567"/>
+            <a:ext cx="8618019" cy="3291840"/>
           </a:xfrm>
           <a:prstGeom prst="rect">
             <a:avLst/>
@@ -5005,7 +5009,7 @@
                 <a:cs typeface="Outfit"/>
                 <a:sym typeface="Outfit"/>
               </a:rPr>
-              <a:t>Today he leads agents as platform users; identity, tools, and the AI gateway; and observability, audit, and cost.</a:t>
+              <a:t>Today he leads agent identity and tools, the AI gateway, and observability.</a:t>
             </a:r>
             <a:endParaRPr lang="en-US" sz="2600" dirty="0"/>
           </a:p>
@@ -5036,31 +5040,55 @@
           </a:p>
         </p:txBody>
       </p:sp>
-      <p:sp>
-        <p:nvSpPr>
-          <p:cNvPr id="20" name="Text 20"/>
-          <p:cNvSpPr txBox="1"/>
-          <p:nvPr/>
-        </p:nvSpPr>
-        <p:spPr>
-          <a:xfrm>
-            <a:off x="2689134" y="3553346"/>
-            <a:ext cx="2442495" cy="2442485"/>
+      <p:pic>
+        <p:nvPicPr>
+          <p:cNvPr id="20" name="Picture 20"/>
+          <p:cNvPicPr>
+            <a:picLocks noChangeAspect="1"/>
+          </p:cNvPicPr>
+          <p:nvPr/>
+        </p:nvPicPr>
+        <p:blipFill>
+          <a:blip r:embed="rId6"/>
+          <a:stretch>
+            <a:fillRect/>
+          </a:stretch>
+        </p:blipFill>
+        <p:spPr>
+          <a:xfrm>
+            <a:off x="8641080" y="7178040"/>
+            <a:ext cx="384048" cy="384048"/>
           </a:xfrm>
           <a:prstGeom prst="rect">
             <a:avLst/>
           </a:prstGeom>
+        </p:spPr>
+      </p:pic>
+      <p:sp>
+        <p:nvSpPr>
+          <p:cNvPr id="21" name="Text 21"/>
+          <p:cNvSpPr txBox="1"/>
+          <p:nvPr/>
+        </p:nvSpPr>
+        <p:spPr>
+          <a:xfrm>
+            <a:off x="9253728" y="7141464"/>
+            <a:ext cx="7772400" cy="457200"/>
+          </a:xfrm>
+          <a:prstGeom prst="rect">
+            <a:avLst/>
+          </a:prstGeom>
           <a:noFill/>
         </p:spPr>
         <p:txBody>
-          <a:bodyPr wrap="square" lIns="0" tIns="0" rIns="0" bIns="0" rtlCol="0" anchor="ctr">
+          <a:bodyPr wrap="square" lIns="0" tIns="0" rIns="0" bIns="0" rtlCol="0" anchor="t">
             <a:noAutofit/>
           </a:bodyPr>
           <a:lstStyle/>
           <a:p>
-            <a:pPr algn="ctr">
+            <a:pPr algn="l">
               <a:lnSpc>
-                <a:spcPts val="8000"/>
+                <a:spcPts val="3640"/>
               </a:lnSpc>
               <a:spcBef>
                 <a:spcPts val="0"/>
@@ -5068,18 +5096,89 @@
               <a:buNone/>
             </a:pPr>
             <a:r>
-              <a:rPr lang="en-US" sz="8000" b="1" dirty="0">
-                <a:solidFill>
-                  <a:srgbClr val="000000"/>
-                </a:solidFill>
-                <a:latin typeface="Outfit Bold"/>
-                <a:ea typeface="Outfit Bold"/>
-                <a:cs typeface="Outfit Bold"/>
-                <a:sym typeface="Outfit Bold"/>
-              </a:rPr>
-              <a:t>RA</a:t>
-            </a:r>
-            <a:endParaRPr lang="en-US" sz="8000" dirty="0"/>
+              <a:rPr lang="en-US" sz="2600" dirty="0">
+                <a:solidFill>
+                  <a:srgbClr val="FFFFFF"/>
+                </a:solidFill>
+                <a:latin typeface="Outfit"/>
+                <a:ea typeface="Outfit"/>
+                <a:cs typeface="Outfit"/>
+                <a:sym typeface="Outfit"/>
+              </a:rPr>
+              <a:t>github.com/kaskol10</a:t>
+            </a:r>
+            <a:endParaRPr lang="en-US" sz="2600" dirty="0"/>
+          </a:p>
+        </p:txBody>
+      </p:sp>
+      <p:pic>
+        <p:nvPicPr>
+          <p:cNvPr id="22" name="Picture 22"/>
+          <p:cNvPicPr>
+            <a:picLocks noChangeAspect="1"/>
+          </p:cNvPicPr>
+          <p:nvPr/>
+        </p:nvPicPr>
+        <p:blipFill>
+          <a:blip r:embed="rId7"/>
+          <a:stretch>
+            <a:fillRect/>
+          </a:stretch>
+        </p:blipFill>
+        <p:spPr>
+          <a:xfrm>
+            <a:off x="8641080" y="7818120"/>
+            <a:ext cx="384048" cy="384048"/>
+          </a:xfrm>
+          <a:prstGeom prst="rect">
+            <a:avLst/>
+          </a:prstGeom>
+        </p:spPr>
+      </p:pic>
+      <p:sp>
+        <p:nvSpPr>
+          <p:cNvPr id="23" name="Text 23"/>
+          <p:cNvSpPr txBox="1"/>
+          <p:nvPr/>
+        </p:nvSpPr>
+        <p:spPr>
+          <a:xfrm>
+            <a:off x="9253728" y="7781544"/>
+            <a:ext cx="7772400" cy="457200"/>
+          </a:xfrm>
+          <a:prstGeom prst="rect">
+            <a:avLst/>
+          </a:prstGeom>
+          <a:noFill/>
+        </p:spPr>
+        <p:txBody>
+          <a:bodyPr wrap="square" lIns="0" tIns="0" rIns="0" bIns="0" rtlCol="0" anchor="t">
+            <a:noAutofit/>
+          </a:bodyPr>
+          <a:lstStyle/>
+          <a:p>
+            <a:pPr algn="l">
+              <a:lnSpc>
+                <a:spcPts val="3640"/>
+              </a:lnSpc>
+              <a:spcBef>
+                <a:spcPts val="0"/>
+              </a:spcBef>
+              <a:buNone/>
+            </a:pPr>
+            <a:r>
+              <a:rPr lang="en-US" sz="2600" dirty="0">
+                <a:solidFill>
+                  <a:srgbClr val="FFFFFF"/>
+                </a:solidFill>
+                <a:latin typeface="Outfit"/>
+                <a:ea typeface="Outfit"/>
+                <a:cs typeface="Outfit"/>
+                <a:sym typeface="Outfit"/>
+              </a:rPr>
+              <a:t>linkedin.com/in/ramiroalvfer</a:t>
+            </a:r>
+            <a:endParaRPr lang="en-US" sz="2600" dirty="0"/>
           </a:p>
         </p:txBody>
       </p:sp>
@@ -5370,9 +5469,12 @@
                 </a:path>
               </a:pathLst>
             </a:custGeom>
-            <a:solidFill>
-              <a:srgbClr val="FFFFFF"/>
-            </a:solidFill>
+            <a:blipFill>
+              <a:blip r:embed="rId5"/>
+              <a:stretch>
+                <a:fillRect/>
+              </a:stretch>
+            </a:blipFill>
           </p:spPr>
           <p:txBody>
             <a:bodyPr/>
@@ -5611,7 +5713,7 @@
         <p:spPr>
           <a:xfrm>
             <a:off x="8641280" y="3521284"/>
-            <a:ext cx="8618019" cy="4422567"/>
+            <a:ext cx="8618019" cy="3291840"/>
           </a:xfrm>
           <a:prstGeom prst="rect">
             <a:avLst/>
@@ -5835,31 +5937,55 @@
           </a:p>
         </p:txBody>
       </p:sp>
-      <p:sp>
-        <p:nvSpPr>
-          <p:cNvPr id="20" name="Text 20"/>
-          <p:cNvSpPr txBox="1"/>
-          <p:nvPr/>
-        </p:nvSpPr>
-        <p:spPr>
-          <a:xfrm>
-            <a:off x="2689134" y="3553346"/>
-            <a:ext cx="2442495" cy="2442485"/>
+      <p:pic>
+        <p:nvPicPr>
+          <p:cNvPr id="20" name="Picture 20"/>
+          <p:cNvPicPr>
+            <a:picLocks noChangeAspect="1"/>
+          </p:cNvPicPr>
+          <p:nvPr/>
+        </p:nvPicPr>
+        <p:blipFill>
+          <a:blip r:embed="rId6"/>
+          <a:stretch>
+            <a:fillRect/>
+          </a:stretch>
+        </p:blipFill>
+        <p:spPr>
+          <a:xfrm>
+            <a:off x="8641080" y="7178040"/>
+            <a:ext cx="384048" cy="384048"/>
           </a:xfrm>
           <a:prstGeom prst="rect">
             <a:avLst/>
           </a:prstGeom>
+        </p:spPr>
+      </p:pic>
+      <p:sp>
+        <p:nvSpPr>
+          <p:cNvPr id="21" name="Text 21"/>
+          <p:cNvSpPr txBox="1"/>
+          <p:nvPr/>
+        </p:nvSpPr>
+        <p:spPr>
+          <a:xfrm>
+            <a:off x="9253728" y="7141464"/>
+            <a:ext cx="7772400" cy="457200"/>
+          </a:xfrm>
+          <a:prstGeom prst="rect">
+            <a:avLst/>
+          </a:prstGeom>
           <a:noFill/>
         </p:spPr>
         <p:txBody>
-          <a:bodyPr wrap="square" lIns="0" tIns="0" rIns="0" bIns="0" rtlCol="0" anchor="ctr">
+          <a:bodyPr wrap="square" lIns="0" tIns="0" rIns="0" bIns="0" rtlCol="0" anchor="t">
             <a:noAutofit/>
           </a:bodyPr>
           <a:lstStyle/>
           <a:p>
-            <a:pPr algn="ctr">
+            <a:pPr algn="l">
               <a:lnSpc>
-                <a:spcPts val="8000"/>
+                <a:spcPts val="3640"/>
               </a:lnSpc>
               <a:spcBef>
                 <a:spcPts val="0"/>
@@ -5867,18 +5993,89 @@
               <a:buNone/>
             </a:pPr>
             <a:r>
-              <a:rPr lang="en-US" sz="8000" b="1" dirty="0">
-                <a:solidFill>
-                  <a:srgbClr val="000000"/>
-                </a:solidFill>
-                <a:latin typeface="Outfit Bold"/>
-                <a:ea typeface="Outfit Bold"/>
-                <a:cs typeface="Outfit Bold"/>
-                <a:sym typeface="Outfit Bold"/>
-              </a:rPr>
-              <a:t>GV</a:t>
-            </a:r>
-            <a:endParaRPr lang="en-US" sz="8000" dirty="0"/>
+              <a:rPr lang="en-US" sz="2600" dirty="0">
+                <a:solidFill>
+                  <a:srgbClr val="FFFFFF"/>
+                </a:solidFill>
+                <a:latin typeface="Outfit"/>
+                <a:ea typeface="Outfit"/>
+                <a:cs typeface="Outfit"/>
+                <a:sym typeface="Outfit"/>
+              </a:rPr>
+              <a:t>github.com/guillermotti</a:t>
+            </a:r>
+            <a:endParaRPr lang="en-US" sz="2600" dirty="0"/>
+          </a:p>
+        </p:txBody>
+      </p:sp>
+      <p:pic>
+        <p:nvPicPr>
+          <p:cNvPr id="22" name="Picture 22"/>
+          <p:cNvPicPr>
+            <a:picLocks noChangeAspect="1"/>
+          </p:cNvPicPr>
+          <p:nvPr/>
+        </p:nvPicPr>
+        <p:blipFill>
+          <a:blip r:embed="rId7"/>
+          <a:stretch>
+            <a:fillRect/>
+          </a:stretch>
+        </p:blipFill>
+        <p:spPr>
+          <a:xfrm>
+            <a:off x="8641080" y="7818120"/>
+            <a:ext cx="384048" cy="384048"/>
+          </a:xfrm>
+          <a:prstGeom prst="rect">
+            <a:avLst/>
+          </a:prstGeom>
+        </p:spPr>
+      </p:pic>
+      <p:sp>
+        <p:nvSpPr>
+          <p:cNvPr id="23" name="Text 23"/>
+          <p:cNvSpPr txBox="1"/>
+          <p:nvPr/>
+        </p:nvSpPr>
+        <p:spPr>
+          <a:xfrm>
+            <a:off x="9253728" y="7781544"/>
+            <a:ext cx="7772400" cy="457200"/>
+          </a:xfrm>
+          <a:prstGeom prst="rect">
+            <a:avLst/>
+          </a:prstGeom>
+          <a:noFill/>
+        </p:spPr>
+        <p:txBody>
+          <a:bodyPr wrap="square" lIns="0" tIns="0" rIns="0" bIns="0" rtlCol="0" anchor="t">
+            <a:noAutofit/>
+          </a:bodyPr>
+          <a:lstStyle/>
+          <a:p>
+            <a:pPr algn="l">
+              <a:lnSpc>
+                <a:spcPts val="3640"/>
+              </a:lnSpc>
+              <a:spcBef>
+                <a:spcPts val="0"/>
+              </a:spcBef>
+              <a:buNone/>
+            </a:pPr>
+            <a:r>
+              <a:rPr lang="en-US" sz="2600" dirty="0">
+                <a:solidFill>
+                  <a:srgbClr val="FFFFFF"/>
+                </a:solidFill>
+                <a:latin typeface="Outfit"/>
+                <a:ea typeface="Outfit"/>
+                <a:cs typeface="Outfit"/>
+                <a:sym typeface="Outfit"/>
+              </a:rPr>
+              <a:t>linkedin.com/in/guillermotti</a:t>
+            </a:r>
+            <a:endParaRPr lang="en-US" sz="2600" dirty="0"/>
           </a:p>
         </p:txBody>
       </p:sp>
@@ -8606,7 +8803,7 @@
                 <a:cs typeface="Outfit"/>
                 <a:sym typeface="Outfit"/>
               </a:rPr>
-              <a:t>Cursor, for the Lab 2 question and auto-onboarding</a:t>
+              <a:t>An agent harness, for the Lab 2 question and auto-onboarding</a:t>
             </a:r>
             <a:endParaRPr lang="en-US" sz="2800" dirty="0"/>
           </a:p>
@@ -12068,7 +12265,7 @@
         <p:spPr>
           <a:xfrm>
             <a:off x="1024128" y="3938016"/>
-            <a:ext cx="16230600" cy="543560"/>
+            <a:ext cx="16230600" cy="1041400"/>
           </a:xfrm>
           <a:prstGeom prst="rect">
             <a:avLst/>
@@ -12100,7 +12297,7 @@
                 <a:cs typeface="Outfit"/>
                 <a:sym typeface="Outfit"/>
               </a:rPr>
-              <a:t>Open Argo CD at http://localhost:8080 and log in as admin:</a:t>
+              <a:t>Every UI is on port 80: http://argocd.localhost, http://langfuse.localhost, http://litellm.localhost, and http://orders.localhost. Log in to Argo CD as admin:</a:t>
             </a:r>
             <a:endParaRPr lang="en-US" sz="2800" dirty="0"/>
           </a:p>
@@ -12114,8 +12311,8 @@
         </p:nvSpPr>
         <p:spPr>
           <a:xfrm>
-            <a:off x="1024128" y="4710176"/>
-            <a:ext cx="16230600" cy="1149096"/>
+            <a:off x="1024128" y="5208016"/>
+            <a:ext cx="16230600" cy="752856"/>
           </a:xfrm>
           <a:prstGeom prst="roundRect">
             <a:avLst>
@@ -12151,27 +12348,6 @@
                 <a:cs typeface="Outfit"/>
                 <a:sym typeface="Outfit"/>
               </a:rPr>
-              <a:t>kubectl -n argocd port-forward svc/argocd-server 8080:80</a:t>
-            </a:r>
-            <a:endParaRPr lang="en-US" sz="2400" dirty="0"/>
-          </a:p>
-          <a:p>
-            <a:pPr algn="l">
-              <a:lnSpc>
-                <a:spcPts val="3120"/>
-              </a:lnSpc>
-              <a:buNone/>
-            </a:pPr>
-            <a:r>
-              <a:rPr lang="en-US" sz="2400" dirty="0">
-                <a:solidFill>
-                  <a:srgbClr val="000000"/>
-                </a:solidFill>
-                <a:latin typeface="Outfit"/>
-                <a:ea typeface="Outfit"/>
-                <a:cs typeface="Outfit"/>
-                <a:sym typeface="Outfit"/>
-              </a:rPr>
               <a:t>kubectl -n argocd get secret argocd-initial-admin-secret -o jsonpath='{.data.password}' | base64 -d</a:t>
             </a:r>
             <a:endParaRPr lang="en-US" sz="2400" dirty="0"/>
@@ -12186,8 +12362,8 @@
         </p:nvSpPr>
         <p:spPr>
           <a:xfrm>
-            <a:off x="1024128" y="6133592"/>
-            <a:ext cx="16230600" cy="1041400"/>
+            <a:off x="1024128" y="6235192"/>
+            <a:ext cx="16230600" cy="543560"/>
           </a:xfrm>
           <a:prstGeom prst="rect">
             <a:avLst/>
@@ -12219,7 +12395,7 @@
                 <a:cs typeface="Outfit"/>
                 <a:sym typeface="Outfit"/>
               </a:rPr>
-              <a:t>If port 8080 is busy, use 8081:80 and http://localhost:8081. Something broken? Reset the cluster. Your fork and pull requests are kept:</a:t>
+              <a:t>Something broken? Reset the cluster. Your fork and pull requests are kept:</a:t>
             </a:r>
             <a:endParaRPr lang="en-US" sz="2800" dirty="0"/>
           </a:p>
@@ -12233,7 +12409,7 @@
         </p:nvSpPr>
         <p:spPr>
           <a:xfrm>
-            <a:off x="1024128" y="7403592"/>
+            <a:off x="1024128" y="7007352"/>
             <a:ext cx="16230600" cy="752856"/>
           </a:xfrm>
           <a:prstGeom prst="roundRect">
@@ -12905,7 +13081,7 @@
         </p:nvGraphicFramePr>
         <p:xfrm>
           <a:off x="1024128" y="2468880"/>
-          <a:ext cx="16230600" cy="6437376"/>
+          <a:ext cx="16230600" cy="6414516"/>
         </p:xfrm>
         <a:graphic>
           <a:graphicData uri="http://schemas.openxmlformats.org/drawingml/2006/table">
@@ -12929,7 +13105,7 @@
                   </a:extLst>
                 </a:gridCol>
               </a:tblGrid>
-              <a:tr h="585216">
+              <a:tr h="534543">
                 <a:tc>
                   <a:txBody>
                     <a:bodyPr/>
@@ -12937,7 +13113,7 @@
                     <a:p>
                       <a:pPr algn="l">
                         <a:lnSpc>
-                          <a:spcPts val="2750"/>
+                          <a:spcPts val="2625"/>
                         </a:lnSpc>
                         <a:spcBef>
                           <a:spcPts val="0"/>
@@ -12945,7 +13121,7 @@
                         <a:buNone/>
                       </a:pPr>
                       <a:r>
-                        <a:rPr lang="en-US" sz="2200" b="1" dirty="0">
+                        <a:rPr lang="en-US" sz="2100" b="1" dirty="0">
                           <a:solidFill>
                             <a:srgbClr val="000000"/>
                           </a:solidFill>
@@ -12956,7 +13132,7 @@
                         </a:rPr>
                         <a:t>Piece</a:t>
                       </a:r>
-                      <a:endParaRPr lang="en-US" sz="2200" dirty="0"/>
+                      <a:endParaRPr lang="en-US" sz="2100" dirty="0"/>
                     </a:p>
                   </a:txBody>
                   <a:tcPr marL="0" marR="182880" marT="0" marB="0" anchor="ctr">
@@ -13002,7 +13178,7 @@
                     <a:p>
                       <a:pPr algn="l">
                         <a:lnSpc>
-                          <a:spcPts val="2750"/>
+                          <a:spcPts val="2625"/>
                         </a:lnSpc>
                         <a:spcBef>
                           <a:spcPts val="0"/>
@@ -13010,7 +13186,7 @@
                         <a:buNone/>
                       </a:pPr>
                       <a:r>
-                        <a:rPr lang="en-US" sz="2200" b="1" dirty="0">
+                        <a:rPr lang="en-US" sz="2100" b="1" dirty="0">
                           <a:solidFill>
                             <a:srgbClr val="000000"/>
                           </a:solidFill>
@@ -13021,7 +13197,7 @@
                         </a:rPr>
                         <a:t>What it does today</a:t>
                       </a:r>
-                      <a:endParaRPr lang="en-US" sz="2200" dirty="0"/>
+                      <a:endParaRPr lang="en-US" sz="2100" dirty="0"/>
                     </a:p>
                   </a:txBody>
                   <a:tcPr marL="0" marR="182880" marT="0" marB="0" anchor="ctr">
@@ -13061,7 +13237,7 @@
                   </a:tcPr>
                 </a:tc>
               </a:tr>
-              <a:tr h="585216">
+              <a:tr h="534543">
                 <a:tc>
                   <a:txBody>
                     <a:bodyPr/>
@@ -13069,7 +13245,7 @@
                     <a:p>
                       <a:pPr algn="l">
                         <a:lnSpc>
-                          <a:spcPts val="2750"/>
+                          <a:spcPts val="2625"/>
                         </a:lnSpc>
                         <a:spcBef>
                           <a:spcPts val="0"/>
@@ -13077,7 +13253,7 @@
                         <a:buNone/>
                       </a:pPr>
                       <a:r>
-                        <a:rPr lang="en-US" sz="2200" dirty="0">
+                        <a:rPr lang="en-US" sz="2100" dirty="0">
                           <a:solidFill>
                             <a:srgbClr val="000000"/>
                           </a:solidFill>
@@ -13088,7 +13264,7 @@
                         </a:rPr>
                         <a:t>kind cluster agentic-idp</a:t>
                       </a:r>
-                      <a:endParaRPr lang="en-US" sz="2200" dirty="0"/>
+                      <a:endParaRPr lang="en-US" sz="2100" dirty="0"/>
                     </a:p>
                   </a:txBody>
                   <a:tcPr marL="0" marR="182880" marT="0" marB="0" anchor="ctr">
@@ -13136,7 +13312,7 @@
                     <a:p>
                       <a:pPr algn="l">
                         <a:lnSpc>
-                          <a:spcPts val="2750"/>
+                          <a:spcPts val="2625"/>
                         </a:lnSpc>
                         <a:spcBef>
                           <a:spcPts val="0"/>
@@ -13144,7 +13320,7 @@
                         <a:buNone/>
                       </a:pPr>
                       <a:r>
-                        <a:rPr lang="en-US" sz="2200" dirty="0">
+                        <a:rPr lang="en-US" sz="2100" dirty="0">
                           <a:solidFill>
                             <a:srgbClr val="000000"/>
                           </a:solidFill>
@@ -13155,7 +13331,7 @@
                         </a:rPr>
                         <a:t>Everything runs here, on your laptop</a:t>
                       </a:r>
-                      <a:endParaRPr lang="en-US" sz="2200" dirty="0"/>
+                      <a:endParaRPr lang="en-US" sz="2100" dirty="0"/>
                     </a:p>
                   </a:txBody>
                   <a:tcPr marL="0" marR="182880" marT="0" marB="0" anchor="ctr">
@@ -13197,7 +13373,7 @@
                   </a:tcPr>
                 </a:tc>
               </a:tr>
-              <a:tr h="585216">
+              <a:tr h="534543">
                 <a:tc>
                   <a:txBody>
                     <a:bodyPr/>
@@ -13205,7 +13381,7 @@
                     <a:p>
                       <a:pPr algn="l">
                         <a:lnSpc>
-                          <a:spcPts val="2750"/>
+                          <a:spcPts val="2625"/>
                         </a:lnSpc>
                         <a:spcBef>
                           <a:spcPts val="0"/>
@@ -13213,7 +13389,7 @@
                         <a:buNone/>
                       </a:pPr>
                       <a:r>
-                        <a:rPr lang="en-US" sz="2200" dirty="0">
+                        <a:rPr lang="en-US" sz="2100" dirty="0">
                           <a:solidFill>
                             <a:srgbClr val="000000"/>
                           </a:solidFill>
@@ -13222,9 +13398,9 @@
                           <a:cs typeface="Outfit"/>
                           <a:sym typeface="Outfit"/>
                         </a:rPr>
-                        <a:t>Your fork, Git, and gh</a:t>
+                        <a:t>API gateway (ingress-nginx)</a:t>
                       </a:r>
-                      <a:endParaRPr lang="en-US" sz="2200" dirty="0"/>
+                      <a:endParaRPr lang="en-US" sz="2100" dirty="0"/>
                     </a:p>
                   </a:txBody>
                   <a:tcPr marL="0" marR="182880" marT="0" marB="0" anchor="ctr">
@@ -13272,7 +13448,7 @@
                     <a:p>
                       <a:pPr algn="l">
                         <a:lnSpc>
-                          <a:spcPts val="2750"/>
+                          <a:spcPts val="2625"/>
                         </a:lnSpc>
                         <a:spcBef>
                           <a:spcPts val="0"/>
@@ -13280,7 +13456,7 @@
                         <a:buNone/>
                       </a:pPr>
                       <a:r>
-                        <a:rPr lang="en-US" sz="2200" dirty="0">
+                        <a:rPr lang="en-US" sz="2100" dirty="0">
                           <a:solidFill>
                             <a:srgbClr val="000000"/>
                           </a:solidFill>
@@ -13289,9 +13465,9 @@
                           <a:cs typeface="Outfit"/>
                           <a:sym typeface="Outfit"/>
                         </a:rPr>
-                        <a:t>The only write path. main is protected by CI checks</a:t>
+                        <a:t>Every web UI on port 80, at *.localhost</a:t>
                       </a:r>
-                      <a:endParaRPr lang="en-US" sz="2200" dirty="0"/>
+                      <a:endParaRPr lang="en-US" sz="2100" dirty="0"/>
                     </a:p>
                   </a:txBody>
                   <a:tcPr marL="0" marR="182880" marT="0" marB="0" anchor="ctr">
@@ -13333,7 +13509,7 @@
                   </a:tcPr>
                 </a:tc>
               </a:tr>
-              <a:tr h="585216">
+              <a:tr h="534543">
                 <a:tc>
                   <a:txBody>
                     <a:bodyPr/>
@@ -13341,7 +13517,7 @@
                     <a:p>
                       <a:pPr algn="l">
                         <a:lnSpc>
-                          <a:spcPts val="2750"/>
+                          <a:spcPts val="2625"/>
                         </a:lnSpc>
                         <a:spcBef>
                           <a:spcPts val="0"/>
@@ -13349,7 +13525,7 @@
                         <a:buNone/>
                       </a:pPr>
                       <a:r>
-                        <a:rPr lang="en-US" sz="2200" dirty="0">
+                        <a:rPr lang="en-US" sz="2100" dirty="0">
                           <a:solidFill>
                             <a:srgbClr val="000000"/>
                           </a:solidFill>
@@ -13358,9 +13534,9 @@
                           <a:cs typeface="Outfit"/>
                           <a:sym typeface="Outfit"/>
                         </a:rPr>
-                        <a:t>Argo CD</a:t>
+                        <a:t>Your fork, Git, and gh</a:t>
                       </a:r>
-                      <a:endParaRPr lang="en-US" sz="2200" dirty="0"/>
+                      <a:endParaRPr lang="en-US" sz="2100" dirty="0"/>
                     </a:p>
                   </a:txBody>
                   <a:tcPr marL="0" marR="182880" marT="0" marB="0" anchor="ctr">
@@ -13408,7 +13584,7 @@
                     <a:p>
                       <a:pPr algn="l">
                         <a:lnSpc>
-                          <a:spcPts val="2750"/>
+                          <a:spcPts val="2625"/>
                         </a:lnSpc>
                         <a:spcBef>
                           <a:spcPts val="0"/>
@@ -13416,7 +13592,7 @@
                         <a:buNone/>
                       </a:pPr>
                       <a:r>
-                        <a:rPr lang="en-US" sz="2200" dirty="0">
+                        <a:rPr lang="en-US" sz="2100" dirty="0">
                           <a:solidFill>
                             <a:srgbClr val="000000"/>
                           </a:solidFill>
@@ -13425,9 +13601,9 @@
                           <a:cs typeface="Outfit"/>
                           <a:sym typeface="Outfit"/>
                         </a:rPr>
-                        <a:t>Syncs every app from your fork and reverts drift</a:t>
+                        <a:t>The only write path. main is protected by CI checks</a:t>
                       </a:r>
-                      <a:endParaRPr lang="en-US" sz="2200" dirty="0"/>
+                      <a:endParaRPr lang="en-US" sz="2100" dirty="0"/>
                     </a:p>
                   </a:txBody>
                   <a:tcPr marL="0" marR="182880" marT="0" marB="0" anchor="ctr">
@@ -13469,7 +13645,7 @@
                   </a:tcPr>
                 </a:tc>
               </a:tr>
-              <a:tr h="585216">
+              <a:tr h="534543">
                 <a:tc>
                   <a:txBody>
                     <a:bodyPr/>
@@ -13477,7 +13653,7 @@
                     <a:p>
                       <a:pPr algn="l">
                         <a:lnSpc>
-                          <a:spcPts val="2750"/>
+                          <a:spcPts val="2625"/>
                         </a:lnSpc>
                         <a:spcBef>
                           <a:spcPts val="0"/>
@@ -13485,7 +13661,7 @@
                         <a:buNone/>
                       </a:pPr>
                       <a:r>
-                        <a:rPr lang="en-US" sz="2200" dirty="0">
+                        <a:rPr lang="en-US" sz="2100" dirty="0">
                           <a:solidFill>
                             <a:srgbClr val="000000"/>
                           </a:solidFill>
@@ -13494,9 +13670,9 @@
                           <a:cs typeface="Outfit"/>
                           <a:sym typeface="Outfit"/>
                         </a:rPr>
-                        <a:t>CI: validate and docs-freshness</a:t>
+                        <a:t>Argo CD</a:t>
                       </a:r>
-                      <a:endParaRPr lang="en-US" sz="2200" dirty="0"/>
+                      <a:endParaRPr lang="en-US" sz="2100" dirty="0"/>
                     </a:p>
                   </a:txBody>
                   <a:tcPr marL="0" marR="182880" marT="0" marB="0" anchor="ctr">
@@ -13544,7 +13720,7 @@
                     <a:p>
                       <a:pPr algn="l">
                         <a:lnSpc>
-                          <a:spcPts val="2750"/>
+                          <a:spcPts val="2625"/>
                         </a:lnSpc>
                         <a:spcBef>
                           <a:spcPts val="0"/>
@@ -13552,7 +13728,7 @@
                         <a:buNone/>
                       </a:pPr>
                       <a:r>
-                        <a:rPr lang="en-US" sz="2200" dirty="0">
+                        <a:rPr lang="en-US" sz="2100" dirty="0">
                           <a:solidFill>
                             <a:srgbClr val="000000"/>
                           </a:solidFill>
@@ -13561,9 +13737,9 @@
                           <a:cs typeface="Outfit"/>
                           <a:sym typeface="Outfit"/>
                         </a:rPr>
-                        <a:t>JSON errors an agent can read; stale docs fail the PR</a:t>
+                        <a:t>Syncs every app from your fork and reverts drift</a:t>
                       </a:r>
-                      <a:endParaRPr lang="en-US" sz="2200" dirty="0"/>
+                      <a:endParaRPr lang="en-US" sz="2100" dirty="0"/>
                     </a:p>
                   </a:txBody>
                   <a:tcPr marL="0" marR="182880" marT="0" marB="0" anchor="ctr">
@@ -13605,7 +13781,7 @@
                   </a:tcPr>
                 </a:tc>
               </a:tr>
-              <a:tr h="585216">
+              <a:tr h="534543">
                 <a:tc>
                   <a:txBody>
                     <a:bodyPr/>
@@ -13613,7 +13789,7 @@
                     <a:p>
                       <a:pPr algn="l">
                         <a:lnSpc>
-                          <a:spcPts val="2750"/>
+                          <a:spcPts val="2625"/>
                         </a:lnSpc>
                         <a:spcBef>
                           <a:spcPts val="0"/>
@@ -13621,7 +13797,7 @@
                         <a:buNone/>
                       </a:pPr>
                       <a:r>
-                        <a:rPr lang="en-US" sz="2200" dirty="0">
+                        <a:rPr lang="en-US" sz="2100" dirty="0">
                           <a:solidFill>
                             <a:srgbClr val="000000"/>
                           </a:solidFill>
@@ -13630,9 +13806,9 @@
                           <a:cs typeface="Outfit"/>
                           <a:sym typeface="Outfit"/>
                         </a:rPr>
-                        <a:t>Prometheus and Alertmanager</a:t>
+                        <a:t>CI: validate and docs-freshness</a:t>
                       </a:r>
-                      <a:endParaRPr lang="en-US" sz="2200" dirty="0"/>
+                      <a:endParaRPr lang="en-US" sz="2100" dirty="0"/>
                     </a:p>
                   </a:txBody>
                   <a:tcPr marL="0" marR="182880" marT="0" marB="0" anchor="ctr">
@@ -13680,7 +13856,7 @@
                     <a:p>
                       <a:pPr algn="l">
                         <a:lnSpc>
-                          <a:spcPts val="2750"/>
+                          <a:spcPts val="2625"/>
                         </a:lnSpc>
                         <a:spcBef>
                           <a:spcPts val="0"/>
@@ -13688,7 +13864,7 @@
                         <a:buNone/>
                       </a:pPr>
                       <a:r>
-                        <a:rPr lang="en-US" sz="2200" dirty="0">
+                        <a:rPr lang="en-US" sz="2100" dirty="0">
                           <a:solidFill>
                             <a:srgbClr val="000000"/>
                           </a:solidFill>
@@ -13697,9 +13873,9 @@
                           <a:cs typeface="Outfit"/>
                           <a:sym typeface="Outfit"/>
                         </a:rPr>
-                        <a:t>Fire the alert and send it to Hermes</a:t>
+                        <a:t>JSON errors an agent can read; stale docs fail the PR</a:t>
                       </a:r>
-                      <a:endParaRPr lang="en-US" sz="2200" dirty="0"/>
+                      <a:endParaRPr lang="en-US" sz="2100" dirty="0"/>
                     </a:p>
                   </a:txBody>
                   <a:tcPr marL="0" marR="182880" marT="0" marB="0" anchor="ctr">
@@ -13741,7 +13917,7 @@
                   </a:tcPr>
                 </a:tc>
               </a:tr>
-              <a:tr h="585216">
+              <a:tr h="534543">
                 <a:tc>
                   <a:txBody>
                     <a:bodyPr/>
@@ -13749,7 +13925,7 @@
                     <a:p>
                       <a:pPr algn="l">
                         <a:lnSpc>
-                          <a:spcPts val="2750"/>
+                          <a:spcPts val="2625"/>
                         </a:lnSpc>
                         <a:spcBef>
                           <a:spcPts val="0"/>
@@ -13757,7 +13933,7 @@
                         <a:buNone/>
                       </a:pPr>
                       <a:r>
-                        <a:rPr lang="en-US" sz="2200" dirty="0">
+                        <a:rPr lang="en-US" sz="2100" dirty="0">
                           <a:solidFill>
                             <a:srgbClr val="000000"/>
                           </a:solidFill>
@@ -13766,9 +13942,9 @@
                           <a:cs typeface="Outfit"/>
                           <a:sym typeface="Outfit"/>
                         </a:rPr>
-                        <a:t>Hermes and k8s-mcp</a:t>
+                        <a:t>Prometheus and Alertmanager</a:t>
                       </a:r>
-                      <a:endParaRPr lang="en-US" sz="2200" dirty="0"/>
+                      <a:endParaRPr lang="en-US" sz="2100" dirty="0"/>
                     </a:p>
                   </a:txBody>
                   <a:tcPr marL="0" marR="182880" marT="0" marB="0" anchor="ctr">
@@ -13816,7 +13992,7 @@
                     <a:p>
                       <a:pPr algn="l">
                         <a:lnSpc>
-                          <a:spcPts val="2750"/>
+                          <a:spcPts val="2625"/>
                         </a:lnSpc>
                         <a:spcBef>
                           <a:spcPts val="0"/>
@@ -13824,7 +14000,7 @@
                         <a:buNone/>
                       </a:pPr>
                       <a:r>
-                        <a:rPr lang="en-US" sz="2200" dirty="0">
+                        <a:rPr lang="en-US" sz="2100" dirty="0">
                           <a:solidFill>
                             <a:srgbClr val="000000"/>
                           </a:solidFill>
@@ -13833,9 +14009,9 @@
                           <a:cs typeface="Outfit"/>
                           <a:sym typeface="Outfit"/>
                         </a:rPr>
-                        <a:t>The triage agent and its read-only Kubernetes tools</a:t>
+                        <a:t>Fire the alert and send it to Hermes</a:t>
                       </a:r>
-                      <a:endParaRPr lang="en-US" sz="2200" dirty="0"/>
+                      <a:endParaRPr lang="en-US" sz="2100" dirty="0"/>
                     </a:p>
                   </a:txBody>
                   <a:tcPr marL="0" marR="182880" marT="0" marB="0" anchor="ctr">
@@ -13877,7 +14053,7 @@
                   </a:tcPr>
                 </a:tc>
               </a:tr>
-              <a:tr h="585216">
+              <a:tr h="534543">
                 <a:tc>
                   <a:txBody>
                     <a:bodyPr/>
@@ -13885,7 +14061,7 @@
                     <a:p>
                       <a:pPr algn="l">
                         <a:lnSpc>
-                          <a:spcPts val="2750"/>
+                          <a:spcPts val="2625"/>
                         </a:lnSpc>
                         <a:spcBef>
                           <a:spcPts val="0"/>
@@ -13893,7 +14069,7 @@
                         <a:buNone/>
                       </a:pPr>
                       <a:r>
-                        <a:rPr lang="en-US" sz="2200" dirty="0">
+                        <a:rPr lang="en-US" sz="2100" dirty="0">
                           <a:solidFill>
                             <a:srgbClr val="000000"/>
                           </a:solidFill>
@@ -13902,9 +14078,9 @@
                           <a:cs typeface="Outfit"/>
                           <a:sym typeface="Outfit"/>
                         </a:rPr>
-                        <a:t>LiteLLM</a:t>
+                        <a:t>Hermes and k8s-mcp</a:t>
                       </a:r>
-                      <a:endParaRPr lang="en-US" sz="2200" dirty="0"/>
+                      <a:endParaRPr lang="en-US" sz="2100" dirty="0"/>
                     </a:p>
                   </a:txBody>
                   <a:tcPr marL="0" marR="182880" marT="0" marB="0" anchor="ctr">
@@ -13952,7 +14128,7 @@
                     <a:p>
                       <a:pPr algn="l">
                         <a:lnSpc>
-                          <a:spcPts val="2750"/>
+                          <a:spcPts val="2625"/>
                         </a:lnSpc>
                         <a:spcBef>
                           <a:spcPts val="0"/>
@@ -13960,7 +14136,7 @@
                         <a:buNone/>
                       </a:pPr>
                       <a:r>
-                        <a:rPr lang="en-US" sz="2200" dirty="0">
+                        <a:rPr lang="en-US" sz="2100" dirty="0">
                           <a:solidFill>
                             <a:srgbClr val="000000"/>
                           </a:solidFill>
@@ -13969,9 +14145,9 @@
                           <a:cs typeface="Outfit"/>
                           <a:sym typeface="Outfit"/>
                         </a:rPr>
-                        <a:t>The AI gateway: one model alias, virtual keys, budgets</a:t>
+                        <a:t>The triage agent and its read-only Kubernetes tools</a:t>
                       </a:r>
-                      <a:endParaRPr lang="en-US" sz="2200" dirty="0"/>
+                      <a:endParaRPr lang="en-US" sz="2100" dirty="0"/>
                     </a:p>
                   </a:txBody>
                   <a:tcPr marL="0" marR="182880" marT="0" marB="0" anchor="ctr">
@@ -14013,7 +14189,7 @@
                   </a:tcPr>
                 </a:tc>
               </a:tr>
-              <a:tr h="585216">
+              <a:tr h="534543">
                 <a:tc>
                   <a:txBody>
                     <a:bodyPr/>
@@ -14021,7 +14197,7 @@
                     <a:p>
                       <a:pPr algn="l">
                         <a:lnSpc>
-                          <a:spcPts val="2750"/>
+                          <a:spcPts val="2625"/>
                         </a:lnSpc>
                         <a:spcBef>
                           <a:spcPts val="0"/>
@@ -14029,7 +14205,7 @@
                         <a:buNone/>
                       </a:pPr>
                       <a:r>
-                        <a:rPr lang="en-US" sz="2200" dirty="0">
+                        <a:rPr lang="en-US" sz="2100" dirty="0">
                           <a:solidFill>
                             <a:srgbClr val="000000"/>
                           </a:solidFill>
@@ -14038,9 +14214,9 @@
                           <a:cs typeface="Outfit"/>
                           <a:sym typeface="Outfit"/>
                         </a:rPr>
-                        <a:t>runbook-bot</a:t>
+                        <a:t>LiteLLM</a:t>
                       </a:r>
-                      <a:endParaRPr lang="en-US" sz="2200" dirty="0"/>
+                      <a:endParaRPr lang="en-US" sz="2100" dirty="0"/>
                     </a:p>
                   </a:txBody>
                   <a:tcPr marL="0" marR="182880" marT="0" marB="0" anchor="ctr">
@@ -14088,7 +14264,7 @@
                     <a:p>
                       <a:pPr algn="l">
                         <a:lnSpc>
-                          <a:spcPts val="2750"/>
+                          <a:spcPts val="2625"/>
                         </a:lnSpc>
                         <a:spcBef>
                           <a:spcPts val="0"/>
@@ -14096,7 +14272,7 @@
                         <a:buNone/>
                       </a:pPr>
                       <a:r>
-                        <a:rPr lang="en-US" sz="2200" dirty="0">
+                        <a:rPr lang="en-US" sz="2100" dirty="0">
                           <a:solidFill>
                             <a:srgbClr val="000000"/>
                           </a:solidFill>
@@ -14105,9 +14281,9 @@
                           <a:cs typeface="Outfit"/>
                           <a:sym typeface="Outfit"/>
                         </a:rPr>
-                        <a:t>The only component with a GitHub token. It only opens PRs</a:t>
+                        <a:t>The AI gateway: one model alias, virtual keys, budgets</a:t>
                       </a:r>
-                      <a:endParaRPr lang="en-US" sz="2200" dirty="0"/>
+                      <a:endParaRPr lang="en-US" sz="2100" dirty="0"/>
                     </a:p>
                   </a:txBody>
                   <a:tcPr marL="0" marR="182880" marT="0" marB="0" anchor="ctr">
@@ -14149,7 +14325,7 @@
                   </a:tcPr>
                 </a:tc>
               </a:tr>
-              <a:tr h="585216">
+              <a:tr h="534543">
                 <a:tc>
                   <a:txBody>
                     <a:bodyPr/>
@@ -14157,7 +14333,7 @@
                     <a:p>
                       <a:pPr algn="l">
                         <a:lnSpc>
-                          <a:spcPts val="2750"/>
+                          <a:spcPts val="2625"/>
                         </a:lnSpc>
                         <a:spcBef>
                           <a:spcPts val="0"/>
@@ -14165,7 +14341,7 @@
                         <a:buNone/>
                       </a:pPr>
                       <a:r>
-                        <a:rPr lang="en-US" sz="2200" dirty="0">
+                        <a:rPr lang="en-US" sz="2100" dirty="0">
                           <a:solidFill>
                             <a:srgbClr val="000000"/>
                           </a:solidFill>
@@ -14174,9 +14350,9 @@
                           <a:cs typeface="Outfit"/>
                           <a:sym typeface="Outfit"/>
                         </a:rPr>
-                        <a:t>Langfuse</a:t>
+                        <a:t>runbook-bot</a:t>
                       </a:r>
-                      <a:endParaRPr lang="en-US" sz="2200" dirty="0"/>
+                      <a:endParaRPr lang="en-US" sz="2100" dirty="0"/>
                     </a:p>
                   </a:txBody>
                   <a:tcPr marL="0" marR="182880" marT="0" marB="0" anchor="ctr">
@@ -14224,7 +14400,7 @@
                     <a:p>
                       <a:pPr algn="l">
                         <a:lnSpc>
-                          <a:spcPts val="2750"/>
+                          <a:spcPts val="2625"/>
                         </a:lnSpc>
                         <a:spcBef>
                           <a:spcPts val="0"/>
@@ -14232,7 +14408,7 @@
                         <a:buNone/>
                       </a:pPr>
                       <a:r>
-                        <a:rPr lang="en-US" sz="2200" dirty="0">
+                        <a:rPr lang="en-US" sz="2100" dirty="0">
                           <a:solidFill>
                             <a:srgbClr val="000000"/>
                           </a:solidFill>
@@ -14241,9 +14417,9 @@
                           <a:cs typeface="Outfit"/>
                           <a:sym typeface="Outfit"/>
                         </a:rPr>
-                        <a:t>Traces of every model call, with tokens and cost</a:t>
+                        <a:t>The only component with a GitHub token. It only opens PRs</a:t>
                       </a:r>
-                      <a:endParaRPr lang="en-US" sz="2200" dirty="0"/>
+                      <a:endParaRPr lang="en-US" sz="2100" dirty="0"/>
                     </a:p>
                   </a:txBody>
                   <a:tcPr marL="0" marR="182880" marT="0" marB="0" anchor="ctr">
@@ -14285,7 +14461,7 @@
                   </a:tcPr>
                 </a:tc>
               </a:tr>
-              <a:tr h="585216">
+              <a:tr h="534543">
                 <a:tc>
                   <a:txBody>
                     <a:bodyPr/>
@@ -14293,7 +14469,7 @@
                     <a:p>
                       <a:pPr algn="l">
                         <a:lnSpc>
-                          <a:spcPts val="2750"/>
+                          <a:spcPts val="2625"/>
                         </a:lnSpc>
                         <a:spcBef>
                           <a:spcPts val="0"/>
@@ -14301,7 +14477,7 @@
                         <a:buNone/>
                       </a:pPr>
                       <a:r>
-                        <a:rPr lang="en-US" sz="2200" dirty="0">
+                        <a:rPr lang="en-US" sz="2100" dirty="0">
                           <a:solidFill>
                             <a:srgbClr val="000000"/>
                           </a:solidFill>
@@ -14310,9 +14486,9 @@
                           <a:cs typeface="Outfit"/>
                           <a:sym typeface="Outfit"/>
                         </a:rPr>
-                        <a:t>Kyverno</a:t>
+                        <a:t>Langfuse</a:t>
                       </a:r>
-                      <a:endParaRPr lang="en-US" sz="2200" dirty="0"/>
+                      <a:endParaRPr lang="en-US" sz="2100" dirty="0"/>
                     </a:p>
                   </a:txBody>
                   <a:tcPr marL="0" marR="182880" marT="0" marB="0" anchor="ctr">
@@ -14360,7 +14536,7 @@
                     <a:p>
                       <a:pPr algn="l">
                         <a:lnSpc>
-                          <a:spcPts val="2750"/>
+                          <a:spcPts val="2625"/>
                         </a:lnSpc>
                         <a:spcBef>
                           <a:spcPts val="0"/>
@@ -14368,7 +14544,143 @@
                         <a:buNone/>
                       </a:pPr>
                       <a:r>
-                        <a:rPr lang="en-US" sz="2200" dirty="0">
+                        <a:rPr lang="en-US" sz="2100" dirty="0">
+                          <a:solidFill>
+                            <a:srgbClr val="000000"/>
+                          </a:solidFill>
+                          <a:latin typeface="Outfit"/>
+                          <a:ea typeface="Outfit"/>
+                          <a:cs typeface="Outfit"/>
+                          <a:sym typeface="Outfit"/>
+                        </a:rPr>
+                        <a:t>Traces of every model call, with tokens and cost</a:t>
+                      </a:r>
+                      <a:endParaRPr lang="en-US" sz="2100" dirty="0"/>
+                    </a:p>
+                  </a:txBody>
+                  <a:tcPr marL="0" marR="182880" marT="0" marB="0" anchor="ctr">
+                    <a:lnL w="12700" cmpd="sng">
+                      <a:noFill/>
+                    </a:lnL>
+                    <a:lnR w="12700" cmpd="sng">
+                      <a:noFill/>
+                    </a:lnR>
+                    <a:lnT w="6350" cap="flat" cmpd="sng" algn="ctr">
+                      <a:solidFill>
+                        <a:schemeClr val="tx1"/>
+                      </a:solidFill>
+                      <a:prstDash val="solid"/>
+                      <a:round/>
+                      <a:headEnd type="none" w="med" len="med"/>
+                      <a:tailEnd type="none" w="med" len="med"/>
+                    </a:lnT>
+                    <a:lnB w="6350" cap="flat" cmpd="sng" algn="ctr">
+                      <a:solidFill>
+                        <a:schemeClr val="accent6">
+                          <a:lumMod val="75000"/>
+                        </a:schemeClr>
+                      </a:solidFill>
+                      <a:prstDash val="solid"/>
+                      <a:round/>
+                      <a:headEnd type="none" w="med" len="med"/>
+                      <a:tailEnd type="none" w="med" len="med"/>
+                    </a:lnB>
+                    <a:lnTlToBr w="12700" cmpd="sng">
+                      <a:noFill/>
+                      <a:prstDash val="solid"/>
+                    </a:lnTlToBr>
+                    <a:lnBlToTr w="12700" cmpd="sng">
+                      <a:noFill/>
+                      <a:prstDash val="solid"/>
+                    </a:lnBlToTr>
+                    <a:noFill/>
+                  </a:tcPr>
+                </a:tc>
+              </a:tr>
+              <a:tr h="534543">
+                <a:tc>
+                  <a:txBody>
+                    <a:bodyPr/>
+                    <a:lstStyle/>
+                    <a:p>
+                      <a:pPr algn="l">
+                        <a:lnSpc>
+                          <a:spcPts val="2625"/>
+                        </a:lnSpc>
+                        <a:spcBef>
+                          <a:spcPts val="0"/>
+                        </a:spcBef>
+                        <a:buNone/>
+                      </a:pPr>
+                      <a:r>
+                        <a:rPr lang="en-US" sz="2100" dirty="0">
+                          <a:solidFill>
+                            <a:srgbClr val="000000"/>
+                          </a:solidFill>
+                          <a:latin typeface="Outfit"/>
+                          <a:ea typeface="Outfit"/>
+                          <a:cs typeface="Outfit"/>
+                          <a:sym typeface="Outfit"/>
+                        </a:rPr>
+                        <a:t>Kyverno</a:t>
+                      </a:r>
+                      <a:endParaRPr lang="en-US" sz="2100" dirty="0"/>
+                    </a:p>
+                  </a:txBody>
+                  <a:tcPr marL="0" marR="182880" marT="0" marB="0" anchor="ctr">
+                    <a:lnL w="12700" cmpd="sng">
+                      <a:noFill/>
+                    </a:lnL>
+                    <a:lnR w="12700" cmpd="sng">
+                      <a:noFill/>
+                    </a:lnR>
+                    <a:lnT w="6350" cap="flat" cmpd="sng" algn="ctr">
+                      <a:solidFill>
+                        <a:schemeClr val="tx1"/>
+                      </a:solidFill>
+                      <a:prstDash val="solid"/>
+                      <a:round/>
+                      <a:headEnd type="none" w="med" len="med"/>
+                      <a:tailEnd type="none" w="med" len="med"/>
+                    </a:lnT>
+                    <a:lnB w="6350" cap="flat" cmpd="sng" algn="ctr">
+                      <a:solidFill>
+                        <a:schemeClr val="accent6">
+                          <a:lumMod val="75000"/>
+                        </a:schemeClr>
+                      </a:solidFill>
+                      <a:prstDash val="solid"/>
+                      <a:round/>
+                      <a:headEnd type="none" w="med" len="med"/>
+                      <a:tailEnd type="none" w="med" len="med"/>
+                    </a:lnB>
+                    <a:lnTlToBr w="12700" cmpd="sng">
+                      <a:noFill/>
+                      <a:prstDash val="solid"/>
+                    </a:lnTlToBr>
+                    <a:lnBlToTr w="12700" cmpd="sng">
+                      <a:noFill/>
+                      <a:prstDash val="solid"/>
+                    </a:lnBlToTr>
+                    <a:noFill/>
+                  </a:tcPr>
+                </a:tc>
+                <a:tc>
+                  <a:txBody>
+                    <a:bodyPr/>
+                    <a:lstStyle/>
+                    <a:p>
+                      <a:pPr algn="l">
+                        <a:lnSpc>
+                          <a:spcPts val="2625"/>
+                        </a:lnSpc>
+                        <a:spcBef>
+                          <a:spcPts val="0"/>
+                        </a:spcBef>
+                        <a:buNone/>
+                      </a:pPr>
+                      <a:r>
+                        <a:rPr lang="en-US" sz="2100" dirty="0">
                           <a:solidFill>
                             <a:srgbClr val="000000"/>
                           </a:solidFill>
@@ -14379,7 +14691,7 @@
                         </a:rPr>
                         <a:t>Policy at admission time, the second layer after RBAC</a:t>
                       </a:r>
-                      <a:endParaRPr lang="en-US" sz="2200" dirty="0"/>
+                      <a:endParaRPr lang="en-US" sz="2100" dirty="0"/>
                     </a:p>
                   </a:txBody>
                   <a:tcPr marL="0" marR="182880" marT="0" marB="0" anchor="ctr">
@@ -14470,7 +14782,7 @@
           <a:bodyPr/>
           <a:lstStyle/>
           <a:p>
-            <a:endParaRPr lang="en-US"/>
+            <a:endParaRPr lang="en-US" dirty="0"/>
           </a:p>
         </p:txBody>
       </p:sp>
@@ -14501,19 +14813,307 @@
           <a:bodyPr/>
           <a:lstStyle/>
           <a:p>
-            <a:endParaRPr lang="en-US"/>
-          </a:p>
-        </p:txBody>
-      </p:sp>
-      <p:sp>
-        <p:nvSpPr>
-          <p:cNvPr id="4" name="TextBox 4"/>
+            <a:endParaRPr lang="en-US" dirty="0"/>
+          </a:p>
+        </p:txBody>
+      </p:sp>
+      <p:grpSp>
+        <p:nvGrpSpPr>
+          <p:cNvPr id="4" name="Group 4"/>
+          <p:cNvGrpSpPr>
+            <a:grpSpLocks noChangeAspect="1"/>
+          </p:cNvGrpSpPr>
+          <p:nvPr/>
+        </p:nvGrpSpPr>
+        <p:grpSpPr>
+          <a:xfrm>
+            <a:off x="16331765" y="473688"/>
+            <a:ext cx="927535" cy="555012"/>
+            <a:chOff x="0" y="0"/>
+            <a:chExt cx="1855064" cy="1110031"/>
+          </a:xfrm>
+        </p:grpSpPr>
+        <p:sp>
+          <p:nvSpPr>
+            <p:cNvPr id="5" name="Freeform 5"/>
+            <p:cNvSpPr/>
+            <p:nvPr/>
+          </p:nvSpPr>
+          <p:spPr>
+            <a:xfrm>
+              <a:off x="63500" y="74168"/>
+              <a:ext cx="498348" cy="727329"/>
+            </a:xfrm>
+            <a:custGeom>
+              <a:avLst/>
+              <a:gdLst/>
+              <a:ahLst/>
+              <a:cxnLst/>
+              <a:rect l="l" t="t" r="r" b="b"/>
+              <a:pathLst>
+                <a:path w="498348" h="727329">
+                  <a:moveTo>
+                    <a:pt x="271526" y="0"/>
+                  </a:moveTo>
+                  <a:lnTo>
+                    <a:pt x="498348" y="0"/>
+                  </a:lnTo>
+                  <a:lnTo>
+                    <a:pt x="213995" y="363601"/>
+                  </a:lnTo>
+                  <a:lnTo>
+                    <a:pt x="498348" y="727329"/>
+                  </a:lnTo>
+                  <a:lnTo>
+                    <a:pt x="271526" y="727329"/>
+                  </a:lnTo>
+                  <a:lnTo>
+                    <a:pt x="0" y="363601"/>
+                  </a:lnTo>
+                  <a:close/>
+                </a:path>
+              </a:pathLst>
+            </a:custGeom>
+            <a:solidFill>
+              <a:srgbClr val="FA7040"/>
+            </a:solidFill>
+          </p:spPr>
+          <p:txBody>
+            <a:bodyPr/>
+            <a:lstStyle/>
+            <a:p>
+              <a:endParaRPr lang="en-US" dirty="0"/>
+            </a:p>
+          </p:txBody>
+        </p:sp>
+        <p:sp>
+          <p:nvSpPr>
+            <p:cNvPr id="6" name="Freeform 6"/>
+            <p:cNvSpPr/>
+            <p:nvPr/>
+          </p:nvSpPr>
+          <p:spPr>
+            <a:xfrm>
+              <a:off x="1293241" y="74168"/>
+              <a:ext cx="498348" cy="727329"/>
+            </a:xfrm>
+            <a:custGeom>
+              <a:avLst/>
+              <a:gdLst/>
+              <a:ahLst/>
+              <a:cxnLst/>
+              <a:rect l="l" t="t" r="r" b="b"/>
+              <a:pathLst>
+                <a:path w="498348" h="727329">
+                  <a:moveTo>
+                    <a:pt x="226822" y="0"/>
+                  </a:moveTo>
+                  <a:lnTo>
+                    <a:pt x="0" y="0"/>
+                  </a:lnTo>
+                  <a:lnTo>
+                    <a:pt x="284353" y="363601"/>
+                  </a:lnTo>
+                  <a:lnTo>
+                    <a:pt x="0" y="727329"/>
+                  </a:lnTo>
+                  <a:lnTo>
+                    <a:pt x="226822" y="727329"/>
+                  </a:lnTo>
+                  <a:lnTo>
+                    <a:pt x="498348" y="363601"/>
+                  </a:lnTo>
+                  <a:close/>
+                </a:path>
+              </a:pathLst>
+            </a:custGeom>
+            <a:solidFill>
+              <a:srgbClr val="FA7040"/>
+            </a:solidFill>
+          </p:spPr>
+          <p:txBody>
+            <a:bodyPr/>
+            <a:lstStyle/>
+            <a:p>
+              <a:endParaRPr lang="en-US" dirty="0"/>
+            </a:p>
+          </p:txBody>
+        </p:sp>
+        <p:sp>
+          <p:nvSpPr>
+            <p:cNvPr id="7" name="Freeform 7"/>
+            <p:cNvSpPr/>
+            <p:nvPr/>
+          </p:nvSpPr>
+          <p:spPr>
+            <a:xfrm>
+              <a:off x="611505" y="63500"/>
+              <a:ext cx="729107" cy="982980"/>
+            </a:xfrm>
+            <a:custGeom>
+              <a:avLst/>
+              <a:gdLst/>
+              <a:ahLst/>
+              <a:cxnLst/>
+              <a:rect l="l" t="t" r="r" b="b"/>
+              <a:pathLst>
+                <a:path w="729107" h="982980">
+                  <a:moveTo>
+                    <a:pt x="563499" y="49657"/>
+                  </a:moveTo>
+                  <a:cubicBezTo>
+                    <a:pt x="512191" y="16510"/>
+                    <a:pt x="454152" y="0"/>
+                    <a:pt x="389255" y="0"/>
+                  </a:cubicBezTo>
+                  <a:cubicBezTo>
+                    <a:pt x="338963" y="0"/>
+                    <a:pt x="293624" y="11049"/>
+                    <a:pt x="253492" y="33147"/>
+                  </a:cubicBezTo>
+                  <a:cubicBezTo>
+                    <a:pt x="229743" y="46228"/>
+                    <a:pt x="208661" y="62103"/>
+                    <a:pt x="190373" y="80645"/>
+                  </a:cubicBezTo>
+                  <a:lnTo>
+                    <a:pt x="190373" y="10668"/>
+                  </a:lnTo>
+                  <a:lnTo>
+                    <a:pt x="0" y="10668"/>
+                  </a:lnTo>
+                  <a:lnTo>
+                    <a:pt x="0" y="982980"/>
+                  </a:lnTo>
+                  <a:lnTo>
+                    <a:pt x="188849" y="982980"/>
+                  </a:lnTo>
+                  <a:lnTo>
+                    <a:pt x="188849" y="678053"/>
+                  </a:lnTo>
+                  <a:cubicBezTo>
+                    <a:pt x="207264" y="696468"/>
+                    <a:pt x="228473" y="712089"/>
+                    <a:pt x="252730" y="725043"/>
+                  </a:cubicBezTo>
+                  <a:cubicBezTo>
+                    <a:pt x="293370" y="746633"/>
+                    <a:pt x="338963" y="757428"/>
+                    <a:pt x="389255" y="757428"/>
+                  </a:cubicBezTo>
+                  <a:cubicBezTo>
+                    <a:pt x="454152" y="757428"/>
+                    <a:pt x="512191" y="740791"/>
+                    <a:pt x="563499" y="707771"/>
+                  </a:cubicBezTo>
+                  <a:cubicBezTo>
+                    <a:pt x="614807" y="674751"/>
+                    <a:pt x="655193" y="629412"/>
+                    <a:pt x="684784" y="572262"/>
+                  </a:cubicBezTo>
+                  <a:cubicBezTo>
+                    <a:pt x="714375" y="515112"/>
+                    <a:pt x="729107" y="450850"/>
+                    <a:pt x="729107" y="379476"/>
+                  </a:cubicBezTo>
+                  <a:cubicBezTo>
+                    <a:pt x="729107" y="307213"/>
+                    <a:pt x="714375" y="242443"/>
+                    <a:pt x="684784" y="185166"/>
+                  </a:cubicBezTo>
+                  <a:cubicBezTo>
+                    <a:pt x="655193" y="127889"/>
+                    <a:pt x="614807" y="82804"/>
+                    <a:pt x="563499" y="49657"/>
+                  </a:cubicBezTo>
+                  <a:moveTo>
+                    <a:pt x="511937" y="481076"/>
+                  </a:moveTo>
+                  <a:cubicBezTo>
+                    <a:pt x="496951" y="510667"/>
+                    <a:pt x="475869" y="533781"/>
+                    <a:pt x="448818" y="550291"/>
+                  </a:cubicBezTo>
+                  <a:cubicBezTo>
+                    <a:pt x="421767" y="566801"/>
+                    <a:pt x="390779" y="575183"/>
+                    <a:pt x="355854" y="575183"/>
+                  </a:cubicBezTo>
+                  <a:cubicBezTo>
+                    <a:pt x="320929" y="575183"/>
+                    <a:pt x="290195" y="566928"/>
+                    <a:pt x="263652" y="550291"/>
+                  </a:cubicBezTo>
+                  <a:cubicBezTo>
+                    <a:pt x="237109" y="533654"/>
+                    <a:pt x="216281" y="510667"/>
+                    <a:pt x="201168" y="481076"/>
+                  </a:cubicBezTo>
+                  <a:cubicBezTo>
+                    <a:pt x="186055" y="451485"/>
+                    <a:pt x="178689" y="417068"/>
+                    <a:pt x="178689" y="377952"/>
+                  </a:cubicBezTo>
+                  <a:cubicBezTo>
+                    <a:pt x="178689" y="339852"/>
+                    <a:pt x="186182" y="305943"/>
+                    <a:pt x="201168" y="276352"/>
+                  </a:cubicBezTo>
+                  <a:cubicBezTo>
+                    <a:pt x="216154" y="246761"/>
+                    <a:pt x="237236" y="223647"/>
+                    <a:pt x="264287" y="207137"/>
+                  </a:cubicBezTo>
+                  <a:cubicBezTo>
+                    <a:pt x="291338" y="190627"/>
+                    <a:pt x="321945" y="182245"/>
+                    <a:pt x="355727" y="182245"/>
+                  </a:cubicBezTo>
+                  <a:cubicBezTo>
+                    <a:pt x="390525" y="182245"/>
+                    <a:pt x="421513" y="190500"/>
+                    <a:pt x="448691" y="207137"/>
+                  </a:cubicBezTo>
+                  <a:cubicBezTo>
+                    <a:pt x="475869" y="223774"/>
+                    <a:pt x="496824" y="246761"/>
+                    <a:pt x="511810" y="276352"/>
+                  </a:cubicBezTo>
+                  <a:cubicBezTo>
+                    <a:pt x="526796" y="305943"/>
+                    <a:pt x="534289" y="339852"/>
+                    <a:pt x="534289" y="377952"/>
+                  </a:cubicBezTo>
+                  <a:cubicBezTo>
+                    <a:pt x="534289" y="417068"/>
+                    <a:pt x="526796" y="451485"/>
+                    <a:pt x="511810" y="481076"/>
+                  </a:cubicBezTo>
+                </a:path>
+              </a:pathLst>
+            </a:custGeom>
+            <a:solidFill>
+              <a:srgbClr val="FA7040"/>
+            </a:solidFill>
+          </p:spPr>
+          <p:txBody>
+            <a:bodyPr/>
+            <a:lstStyle/>
+            <a:p>
+              <a:endParaRPr lang="en-US" dirty="0"/>
+            </a:p>
+          </p:txBody>
+        </p:sp>
+      </p:grpSp>
+      <p:sp>
+        <p:nvSpPr>
+          <p:cNvPr id="8" name="TextBox 8"/>
           <p:cNvSpPr txBox="1"/>
           <p:nvPr/>
         </p:nvSpPr>
         <p:spPr>
           <a:xfrm>
-            <a:off x="1024128" y="1461010"/>
+            <a:off x="1024128" y="1236622"/>
             <a:ext cx="15087600" cy="863600"/>
           </a:xfrm>
           <a:prstGeom prst="rect">
@@ -14521,7 +15121,7 @@
           </a:prstGeom>
         </p:spPr>
         <p:txBody>
-          <a:bodyPr lIns="0" tIns="0" rIns="0" bIns="0" rtlCol="0" anchor="t" wrap="square">
+          <a:bodyPr wrap="square" lIns="0" tIns="0" rIns="0" bIns="0" rtlCol="0" anchor="t">
             <a:spAutoFit/>
           </a:bodyPr>
           <a:lstStyle/>
@@ -14545,7 +15145,7 @@
                 <a:cs typeface="Outfit Bold"/>
                 <a:sym typeface="Outfit Bold"/>
               </a:rPr>
-              <a:t>How the labs fit together</a:t>
+              <a:t>How the pieces connect</a:t>
             </a:r>
             <a:endParaRPr lang="en-US" sz="5000" dirty="0"/>
           </a:p>
@@ -14553,7 +15153,7 @@
       </p:sp>
       <p:sp>
         <p:nvSpPr>
-          <p:cNvPr id="5" name="TextBox 5"/>
+          <p:cNvPr id="9" name="TextBox 9"/>
           <p:cNvSpPr txBox="1"/>
           <p:nvPr/>
         </p:nvSpPr>
@@ -14578,7 +15178,7 @@
               </a:lnSpc>
             </a:pPr>
             <a:r>
-              <a:rPr lang="en-US" sz="5199" b="1">
+              <a:rPr lang="en-US" sz="5199" b="1" dirty="0">
                 <a:solidFill>
                   <a:srgbClr val="F97141"/>
                 </a:solidFill>
@@ -14594,14 +15194,14 @@
       </p:sp>
       <p:sp>
         <p:nvSpPr>
-          <p:cNvPr id="6" name="TextBox 6"/>
+          <p:cNvPr id="10" name="TextBox 10"/>
           <p:cNvSpPr txBox="1"/>
           <p:nvPr/>
         </p:nvSpPr>
         <p:spPr>
           <a:xfrm>
-            <a:off x="1256705" y="9549448"/>
-            <a:ext cx="1463040" cy="418956"/>
+            <a:off x="1028700" y="9397049"/>
+            <a:ext cx="1463040" cy="405764"/>
           </a:xfrm>
           <a:prstGeom prst="rect">
             <a:avLst/>
@@ -14633,6 +15233,1970 @@
                 <a:sym typeface="Outfit"/>
               </a:rPr>
               <a:t>Pg: 11</a:t>
+            </a:r>
+            <a:endParaRPr lang="en-US" sz="2400" dirty="0"/>
+          </a:p>
+        </p:txBody>
+      </p:sp>
+      <p:sp>
+        <p:nvSpPr>
+          <p:cNvPr id="11" name="TextBox 11"/>
+          <p:cNvSpPr txBox="1"/>
+          <p:nvPr/>
+        </p:nvSpPr>
+        <p:spPr>
+          <a:xfrm>
+            <a:off x="1028700" y="441961"/>
+            <a:ext cx="12801600" cy="405764"/>
+          </a:xfrm>
+          <a:prstGeom prst="rect">
+            <a:avLst/>
+          </a:prstGeom>
+        </p:spPr>
+        <p:txBody>
+          <a:bodyPr wrap="square" lIns="0" tIns="0" rIns="0" bIns="0" rtlCol="0" anchor="t">
+            <a:spAutoFit/>
+          </a:bodyPr>
+          <a:lstStyle/>
+          <a:p>
+            <a:pPr algn="l">
+              <a:lnSpc>
+                <a:spcPts val="3360"/>
+              </a:lnSpc>
+              <a:spcBef>
+                <a:spcPts val="0"/>
+              </a:spcBef>
+              <a:buNone/>
+            </a:pPr>
+            <a:r>
+              <a:rPr lang="en-US" sz="2400" dirty="0">
+                <a:solidFill>
+                  <a:srgbClr val="000000"/>
+                </a:solidFill>
+                <a:latin typeface="Outfit"/>
+                <a:ea typeface="Outfit"/>
+                <a:cs typeface="Outfit"/>
+                <a:sym typeface="Outfit"/>
+              </a:rPr>
+              <a:t>Before the session</a:t>
+            </a:r>
+            <a:endParaRPr lang="en-US" sz="2400" dirty="0"/>
+          </a:p>
+        </p:txBody>
+      </p:sp>
+      <p:sp>
+        <p:nvSpPr>
+          <p:cNvPr id="12" name="Box 12"/>
+          <p:cNvSpPr/>
+          <p:nvPr/>
+        </p:nvSpPr>
+        <p:spPr>
+          <a:xfrm>
+            <a:off x="4297680" y="2331720"/>
+            <a:ext cx="12966192" cy="6720840"/>
+          </a:xfrm>
+          <a:prstGeom prst="rect">
+            <a:avLst>
+              <a:gd name="adj" fmla="val 10000"/>
+            </a:avLst>
+          </a:prstGeom>
+          <a:noFill/>
+          <a:ln w="19050">
+            <a:solidFill>
+              <a:srgbClr val="595959"/>
+            </a:solidFill>
+          </a:ln>
+        </p:spPr>
+        <p:txBody>
+          <a:bodyPr wrap="square" lIns="128016" tIns="128016" rIns="128016" bIns="128016" rtlCol="0" anchor="ctr">
+            <a:noAutofit/>
+          </a:bodyPr>
+          <a:lstStyle/>
+          <a:p>
+            <a:pPr algn="ctr">
+              <a:lnSpc>
+                <a:spcPts val="2640"/>
+              </a:lnSpc>
+              <a:spcBef>
+                <a:spcPts val="0"/>
+              </a:spcBef>
+              <a:buNone/>
+            </a:pPr>
+            <a:endParaRPr lang="en-US" sz="2200" dirty="0"/>
+          </a:p>
+        </p:txBody>
+      </p:sp>
+      <p:sp>
+        <p:nvSpPr>
+          <p:cNvPr id="13" name="Text 13"/>
+          <p:cNvSpPr txBox="1"/>
+          <p:nvPr/>
+        </p:nvSpPr>
+        <p:spPr>
+          <a:xfrm>
+            <a:off x="4526280" y="2395728"/>
+            <a:ext cx="7315200" cy="365760"/>
+          </a:xfrm>
+          <a:prstGeom prst="rect">
+            <a:avLst/>
+          </a:prstGeom>
+          <a:noFill/>
+        </p:spPr>
+        <p:txBody>
+          <a:bodyPr wrap="square" lIns="0" tIns="0" rIns="0" bIns="0" rtlCol="0" anchor="t">
+            <a:noAutofit/>
+          </a:bodyPr>
+          <a:lstStyle/>
+          <a:p>
+            <a:pPr algn="l">
+              <a:lnSpc>
+                <a:spcPts val="2520"/>
+              </a:lnSpc>
+              <a:spcBef>
+                <a:spcPts val="0"/>
+              </a:spcBef>
+              <a:buNone/>
+            </a:pPr>
+            <a:r>
+              <a:rPr lang="en-US" sz="1800" b="1" dirty="0">
+                <a:solidFill>
+                  <a:srgbClr val="595959"/>
+                </a:solidFill>
+                <a:latin typeface="Outfit Bold"/>
+                <a:ea typeface="Outfit Bold"/>
+                <a:cs typeface="Outfit Bold"/>
+                <a:sym typeface="Outfit Bold"/>
+              </a:rPr>
+              <a:t>kind cluster: agentic-idp</a:t>
+            </a:r>
+            <a:endParaRPr lang="en-US" sz="1800" dirty="0"/>
+          </a:p>
+        </p:txBody>
+      </p:sp>
+      <p:sp>
+        <p:nvSpPr>
+          <p:cNvPr id="14" name="Box 14"/>
+          <p:cNvSpPr/>
+          <p:nvPr/>
+        </p:nvSpPr>
+        <p:spPr>
+          <a:xfrm>
+            <a:off x="4526280" y="2834640"/>
+            <a:ext cx="12508992" cy="868680"/>
+          </a:xfrm>
+          <a:prstGeom prst="roundRect">
+            <a:avLst>
+              <a:gd name="adj" fmla="val 10000"/>
+            </a:avLst>
+          </a:prstGeom>
+          <a:solidFill>
+            <a:srgbClr val="000000"/>
+          </a:solidFill>
+          <a:ln>
+            <a:noFill/>
+          </a:ln>
+        </p:spPr>
+        <p:txBody>
+          <a:bodyPr wrap="square" lIns="128016" tIns="128016" rIns="128016" bIns="128016" rtlCol="0" anchor="ctr">
+            <a:noAutofit/>
+          </a:bodyPr>
+          <a:lstStyle/>
+          <a:p>
+            <a:pPr algn="ctr">
+              <a:lnSpc>
+                <a:spcPts val="2400"/>
+              </a:lnSpc>
+              <a:spcBef>
+                <a:spcPts val="0"/>
+              </a:spcBef>
+              <a:buNone/>
+            </a:pPr>
+            <a:r>
+              <a:rPr lang="en-US" sz="2000" b="1" dirty="0">
+                <a:solidFill>
+                  <a:srgbClr val="FFFFFF"/>
+                </a:solidFill>
+                <a:latin typeface="Outfit Bold"/>
+                <a:ea typeface="Outfit Bold"/>
+                <a:cs typeface="Outfit Bold"/>
+                <a:sym typeface="Outfit Bold"/>
+              </a:rPr>
+              <a:t>API gateway (ingress-nginx)</a:t>
+            </a:r>
+            <a:endParaRPr lang="en-US" sz="2000" dirty="0"/>
+          </a:p>
+          <a:p>
+            <a:pPr algn="ctr">
+              <a:lnSpc>
+                <a:spcPts val="2040"/>
+              </a:lnSpc>
+              <a:spcBef>
+                <a:spcPts val="200"/>
+              </a:spcBef>
+              <a:buNone/>
+            </a:pPr>
+            <a:r>
+              <a:rPr lang="en-US" sz="1700" dirty="0">
+                <a:solidFill>
+                  <a:srgbClr val="FFFFFF"/>
+                </a:solidFill>
+                <a:latin typeface="Outfit"/>
+                <a:ea typeface="Outfit"/>
+                <a:cs typeface="Outfit"/>
+                <a:sym typeface="Outfit"/>
+              </a:rPr>
+              <a:t>argocd · langfuse · litellm · orders, at *.localhost on port 80</a:t>
+            </a:r>
+            <a:endParaRPr lang="en-US" sz="1700" dirty="0"/>
+          </a:p>
+        </p:txBody>
+      </p:sp>
+      <p:sp>
+        <p:nvSpPr>
+          <p:cNvPr id="15" name="Box 15"/>
+          <p:cNvSpPr/>
+          <p:nvPr/>
+        </p:nvSpPr>
+        <p:spPr>
+          <a:xfrm>
+            <a:off x="1024128" y="2834640"/>
+            <a:ext cx="2834640" cy="868680"/>
+          </a:xfrm>
+          <a:prstGeom prst="roundRect">
+            <a:avLst>
+              <a:gd name="adj" fmla="val 10000"/>
+            </a:avLst>
+          </a:prstGeom>
+          <a:solidFill>
+            <a:srgbClr val="FFFFFF"/>
+          </a:solidFill>
+          <a:ln w="19050">
+            <a:solidFill>
+              <a:srgbClr val="000000"/>
+            </a:solidFill>
+          </a:ln>
+        </p:spPr>
+        <p:txBody>
+          <a:bodyPr wrap="square" lIns="128016" tIns="128016" rIns="128016" bIns="128016" rtlCol="0" anchor="ctr">
+            <a:noAutofit/>
+          </a:bodyPr>
+          <a:lstStyle/>
+          <a:p>
+            <a:pPr algn="ctr">
+              <a:lnSpc>
+                <a:spcPts val="2400"/>
+              </a:lnSpc>
+              <a:spcBef>
+                <a:spcPts val="0"/>
+              </a:spcBef>
+              <a:buNone/>
+            </a:pPr>
+            <a:r>
+              <a:rPr lang="en-US" sz="2000" b="1" dirty="0">
+                <a:solidFill>
+                  <a:srgbClr val="000000"/>
+                </a:solidFill>
+                <a:latin typeface="Outfit Bold"/>
+                <a:ea typeface="Outfit Bold"/>
+                <a:cs typeface="Outfit Bold"/>
+                <a:sym typeface="Outfit Bold"/>
+              </a:rPr>
+              <a:t>You</a:t>
+            </a:r>
+            <a:endParaRPr lang="en-US" sz="2000" dirty="0"/>
+          </a:p>
+          <a:p>
+            <a:pPr algn="ctr">
+              <a:lnSpc>
+                <a:spcPts val="2040"/>
+              </a:lnSpc>
+              <a:spcBef>
+                <a:spcPts val="200"/>
+              </a:spcBef>
+              <a:buNone/>
+            </a:pPr>
+            <a:r>
+              <a:rPr lang="en-US" sz="1700" dirty="0">
+                <a:solidFill>
+                  <a:srgbClr val="000000"/>
+                </a:solidFill>
+                <a:latin typeface="Outfit"/>
+                <a:ea typeface="Outfit"/>
+                <a:cs typeface="Outfit"/>
+                <a:sym typeface="Outfit"/>
+              </a:rPr>
+              <a:t>and an agent harness</a:t>
+            </a:r>
+            <a:endParaRPr lang="en-US" sz="1700" dirty="0"/>
+          </a:p>
+        </p:txBody>
+      </p:sp>
+      <p:sp>
+        <p:nvSpPr>
+          <p:cNvPr id="16" name="Box 16"/>
+          <p:cNvSpPr/>
+          <p:nvPr/>
+        </p:nvSpPr>
+        <p:spPr>
+          <a:xfrm>
+            <a:off x="1024128" y="4069080"/>
+            <a:ext cx="2834640" cy="2926080"/>
+          </a:xfrm>
+          <a:prstGeom prst="roundRect">
+            <a:avLst>
+              <a:gd name="adj" fmla="val 10000"/>
+            </a:avLst>
+          </a:prstGeom>
+          <a:solidFill>
+            <a:srgbClr val="FFFFFF"/>
+          </a:solidFill>
+          <a:ln w="19050">
+            <a:solidFill>
+              <a:srgbClr val="000000"/>
+            </a:solidFill>
+          </a:ln>
+        </p:spPr>
+        <p:txBody>
+          <a:bodyPr wrap="square" lIns="128016" tIns="128016" rIns="128016" bIns="128016" rtlCol="0" anchor="ctr">
+            <a:noAutofit/>
+          </a:bodyPr>
+          <a:lstStyle/>
+          <a:p>
+            <a:pPr algn="ctr">
+              <a:lnSpc>
+                <a:spcPts val="2640"/>
+              </a:lnSpc>
+              <a:spcBef>
+                <a:spcPts val="0"/>
+              </a:spcBef>
+              <a:buNone/>
+            </a:pPr>
+            <a:r>
+              <a:rPr lang="en-US" sz="2200" b="1" dirty="0">
+                <a:solidFill>
+                  <a:srgbClr val="000000"/>
+                </a:solidFill>
+                <a:latin typeface="Outfit Bold"/>
+                <a:ea typeface="Outfit Bold"/>
+                <a:cs typeface="Outfit Bold"/>
+                <a:sym typeface="Outfit Bold"/>
+              </a:rPr>
+              <a:t>GitHub: your fork</a:t>
+            </a:r>
+            <a:endParaRPr lang="en-US" sz="2200" dirty="0"/>
+          </a:p>
+          <a:p>
+            <a:pPr algn="ctr">
+              <a:lnSpc>
+                <a:spcPts val="2040"/>
+              </a:lnSpc>
+              <a:spcBef>
+                <a:spcPts val="200"/>
+              </a:spcBef>
+              <a:buNone/>
+            </a:pPr>
+            <a:r>
+              <a:rPr lang="en-US" sz="1700" dirty="0">
+                <a:solidFill>
+                  <a:srgbClr val="000000"/>
+                </a:solidFill>
+                <a:latin typeface="Outfit"/>
+                <a:ea typeface="Outfit"/>
+                <a:cs typeface="Outfit"/>
+                <a:sym typeface="Outfit"/>
+              </a:rPr>
+              <a:t>CI checks protect main. Argo CD polls it; runbook-bot opens PRs on it.</a:t>
+            </a:r>
+            <a:endParaRPr lang="en-US" sz="1700" dirty="0"/>
+          </a:p>
+        </p:txBody>
+      </p:sp>
+      <p:sp>
+        <p:nvSpPr>
+          <p:cNvPr id="17" name="Box 17"/>
+          <p:cNvSpPr/>
+          <p:nvPr/>
+        </p:nvSpPr>
+        <p:spPr>
+          <a:xfrm>
+            <a:off x="1024128" y="7360920"/>
+            <a:ext cx="2834640" cy="1280160"/>
+          </a:xfrm>
+          <a:prstGeom prst="roundRect">
+            <a:avLst>
+              <a:gd name="adj" fmla="val 10000"/>
+            </a:avLst>
+          </a:prstGeom>
+          <a:solidFill>
+            <a:srgbClr val="FFFFFF"/>
+          </a:solidFill>
+          <a:ln w="19050">
+            <a:solidFill>
+              <a:srgbClr val="000000"/>
+            </a:solidFill>
+          </a:ln>
+        </p:spPr>
+        <p:txBody>
+          <a:bodyPr wrap="square" lIns="128016" tIns="128016" rIns="128016" bIns="128016" rtlCol="0" anchor="ctr">
+            <a:noAutofit/>
+          </a:bodyPr>
+          <a:lstStyle/>
+          <a:p>
+            <a:pPr algn="ctr">
+              <a:lnSpc>
+                <a:spcPts val="2640"/>
+              </a:lnSpc>
+              <a:spcBef>
+                <a:spcPts val="0"/>
+              </a:spcBef>
+              <a:buNone/>
+            </a:pPr>
+            <a:r>
+              <a:rPr lang="en-US" sz="2200" b="1" dirty="0">
+                <a:solidFill>
+                  <a:srgbClr val="000000"/>
+                </a:solidFill>
+                <a:latin typeface="Outfit Bold"/>
+                <a:ea typeface="Outfit Bold"/>
+                <a:cs typeface="Outfit Bold"/>
+                <a:sym typeface="Outfit Bold"/>
+              </a:rPr>
+              <a:t>OpenRouter</a:t>
+            </a:r>
+            <a:endParaRPr lang="en-US" sz="2200" dirty="0"/>
+          </a:p>
+          <a:p>
+            <a:pPr algn="ctr">
+              <a:lnSpc>
+                <a:spcPts val="2040"/>
+              </a:lnSpc>
+              <a:spcBef>
+                <a:spcPts val="200"/>
+              </a:spcBef>
+              <a:buNone/>
+            </a:pPr>
+            <a:r>
+              <a:rPr lang="en-US" sz="1700" dirty="0">
+                <a:solidFill>
+                  <a:srgbClr val="000000"/>
+                </a:solidFill>
+                <a:latin typeface="Outfit"/>
+                <a:ea typeface="Outfit"/>
+                <a:cs typeface="Outfit"/>
+                <a:sym typeface="Outfit"/>
+              </a:rPr>
+              <a:t>the model provider</a:t>
+            </a:r>
+            <a:endParaRPr lang="en-US" sz="1700" dirty="0"/>
+          </a:p>
+        </p:txBody>
+      </p:sp>
+      <p:sp>
+        <p:nvSpPr>
+          <p:cNvPr id="18" name="Box 18"/>
+          <p:cNvSpPr/>
+          <p:nvPr/>
+        </p:nvSpPr>
+        <p:spPr>
+          <a:xfrm>
+            <a:off x="4526280" y="4069080"/>
+            <a:ext cx="2647188" cy="1280160"/>
+          </a:xfrm>
+          <a:prstGeom prst="roundRect">
+            <a:avLst>
+              <a:gd name="adj" fmla="val 10000"/>
+            </a:avLst>
+          </a:prstGeom>
+          <a:solidFill>
+            <a:srgbClr val="E1E1E1"/>
+          </a:solidFill>
+          <a:ln>
+            <a:noFill/>
+          </a:ln>
+        </p:spPr>
+        <p:txBody>
+          <a:bodyPr wrap="square" lIns="128016" tIns="128016" rIns="128016" bIns="128016" rtlCol="0" anchor="ctr">
+            <a:noAutofit/>
+          </a:bodyPr>
+          <a:lstStyle/>
+          <a:p>
+            <a:pPr algn="ctr">
+              <a:lnSpc>
+                <a:spcPts val="2640"/>
+              </a:lnSpc>
+              <a:spcBef>
+                <a:spcPts val="0"/>
+              </a:spcBef>
+              <a:buNone/>
+            </a:pPr>
+            <a:r>
+              <a:rPr lang="en-US" sz="2200" b="1" dirty="0">
+                <a:solidFill>
+                  <a:srgbClr val="000000"/>
+                </a:solidFill>
+                <a:latin typeface="Outfit Bold"/>
+                <a:ea typeface="Outfit Bold"/>
+                <a:cs typeface="Outfit Bold"/>
+                <a:sym typeface="Outfit Bold"/>
+              </a:rPr>
+              <a:t>Argo CD</a:t>
+            </a:r>
+            <a:endParaRPr lang="en-US" sz="2200" dirty="0"/>
+          </a:p>
+          <a:p>
+            <a:pPr algn="ctr">
+              <a:lnSpc>
+                <a:spcPts val="2040"/>
+              </a:lnSpc>
+              <a:spcBef>
+                <a:spcPts val="200"/>
+              </a:spcBef>
+              <a:buNone/>
+            </a:pPr>
+            <a:r>
+              <a:rPr lang="en-US" sz="1700" dirty="0">
+                <a:solidFill>
+                  <a:srgbClr val="000000"/>
+                </a:solidFill>
+                <a:latin typeface="Outfit"/>
+                <a:ea typeface="Outfit"/>
+                <a:cs typeface="Outfit"/>
+                <a:sym typeface="Outfit"/>
+              </a:rPr>
+              <a:t>syncs every app from your fork</a:t>
+            </a:r>
+            <a:endParaRPr lang="en-US" sz="1700" dirty="0"/>
+          </a:p>
+        </p:txBody>
+      </p:sp>
+      <p:sp>
+        <p:nvSpPr>
+          <p:cNvPr id="19" name="Box 19"/>
+          <p:cNvSpPr/>
+          <p:nvPr/>
+        </p:nvSpPr>
+        <p:spPr>
+          <a:xfrm>
+            <a:off x="7813548" y="4069080"/>
+            <a:ext cx="2647188" cy="1280160"/>
+          </a:xfrm>
+          <a:prstGeom prst="roundRect">
+            <a:avLst>
+              <a:gd name="adj" fmla="val 10000"/>
+            </a:avLst>
+          </a:prstGeom>
+          <a:solidFill>
+            <a:srgbClr val="E1E1E1"/>
+          </a:solidFill>
+          <a:ln>
+            <a:noFill/>
+          </a:ln>
+        </p:spPr>
+        <p:txBody>
+          <a:bodyPr wrap="square" lIns="128016" tIns="128016" rIns="128016" bIns="128016" rtlCol="0" anchor="ctr">
+            <a:noAutofit/>
+          </a:bodyPr>
+          <a:lstStyle/>
+          <a:p>
+            <a:pPr algn="ctr">
+              <a:lnSpc>
+                <a:spcPts val="2640"/>
+              </a:lnSpc>
+              <a:spcBef>
+                <a:spcPts val="0"/>
+              </a:spcBef>
+              <a:buNone/>
+            </a:pPr>
+            <a:r>
+              <a:rPr lang="en-US" sz="2200" b="1" dirty="0">
+                <a:solidFill>
+                  <a:srgbClr val="000000"/>
+                </a:solidFill>
+                <a:latin typeface="Outfit Bold"/>
+                <a:ea typeface="Outfit Bold"/>
+                <a:cs typeface="Outfit Bold"/>
+                <a:sym typeface="Outfit Bold"/>
+              </a:rPr>
+              <a:t>Prometheus</a:t>
+            </a:r>
+            <a:endParaRPr lang="en-US" sz="2200" dirty="0"/>
+          </a:p>
+          <a:p>
+            <a:pPr algn="ctr">
+              <a:lnSpc>
+                <a:spcPts val="2040"/>
+              </a:lnSpc>
+              <a:spcBef>
+                <a:spcPts val="200"/>
+              </a:spcBef>
+              <a:buNone/>
+            </a:pPr>
+            <a:r>
+              <a:rPr lang="en-US" sz="1700" dirty="0">
+                <a:solidFill>
+                  <a:srgbClr val="000000"/>
+                </a:solidFill>
+                <a:latin typeface="Outfit"/>
+                <a:ea typeface="Outfit"/>
+                <a:cs typeface="Outfit"/>
+                <a:sym typeface="Outfit"/>
+              </a:rPr>
+              <a:t>and Alertmanager fire the alert</a:t>
+            </a:r>
+            <a:endParaRPr lang="en-US" sz="1700" dirty="0"/>
+          </a:p>
+        </p:txBody>
+      </p:sp>
+      <p:sp>
+        <p:nvSpPr>
+          <p:cNvPr id="20" name="Box 20"/>
+          <p:cNvSpPr/>
+          <p:nvPr/>
+        </p:nvSpPr>
+        <p:spPr>
+          <a:xfrm>
+            <a:off x="11100816" y="4069080"/>
+            <a:ext cx="2647188" cy="1280160"/>
+          </a:xfrm>
+          <a:prstGeom prst="roundRect">
+            <a:avLst>
+              <a:gd name="adj" fmla="val 10000"/>
+            </a:avLst>
+          </a:prstGeom>
+          <a:solidFill>
+            <a:srgbClr val="E1E1E1"/>
+          </a:solidFill>
+          <a:ln>
+            <a:noFill/>
+          </a:ln>
+        </p:spPr>
+        <p:txBody>
+          <a:bodyPr wrap="square" lIns="128016" tIns="128016" rIns="128016" bIns="128016" rtlCol="0" anchor="ctr">
+            <a:noAutofit/>
+          </a:bodyPr>
+          <a:lstStyle/>
+          <a:p>
+            <a:pPr algn="ctr">
+              <a:lnSpc>
+                <a:spcPts val="2640"/>
+              </a:lnSpc>
+              <a:spcBef>
+                <a:spcPts val="0"/>
+              </a:spcBef>
+              <a:buNone/>
+            </a:pPr>
+            <a:r>
+              <a:rPr lang="en-US" sz="2200" b="1" dirty="0">
+                <a:solidFill>
+                  <a:srgbClr val="000000"/>
+                </a:solidFill>
+                <a:latin typeface="Outfit Bold"/>
+                <a:ea typeface="Outfit Bold"/>
+                <a:cs typeface="Outfit Bold"/>
+                <a:sym typeface="Outfit Bold"/>
+              </a:rPr>
+              <a:t>orders</a:t>
+            </a:r>
+            <a:endParaRPr lang="en-US" sz="2200" dirty="0"/>
+          </a:p>
+          <a:p>
+            <a:pPr algn="ctr">
+              <a:lnSpc>
+                <a:spcPts val="2040"/>
+              </a:lnSpc>
+              <a:spcBef>
+                <a:spcPts val="200"/>
+              </a:spcBef>
+              <a:buNone/>
+            </a:pPr>
+            <a:r>
+              <a:rPr lang="en-US" sz="1700" dirty="0">
+                <a:solidFill>
+                  <a:srgbClr val="000000"/>
+                </a:solidFill>
+                <a:latin typeface="Outfit"/>
+                <a:ea typeface="Outfit"/>
+                <a:cs typeface="Outfit"/>
+                <a:sym typeface="Outfit"/>
+              </a:rPr>
+              <a:t>the service, in shop</a:t>
+            </a:r>
+            <a:endParaRPr lang="en-US" sz="1700" dirty="0"/>
+          </a:p>
+        </p:txBody>
+      </p:sp>
+      <p:sp>
+        <p:nvSpPr>
+          <p:cNvPr id="21" name="Box 21"/>
+          <p:cNvSpPr/>
+          <p:nvPr/>
+        </p:nvSpPr>
+        <p:spPr>
+          <a:xfrm>
+            <a:off x="14388084" y="4069080"/>
+            <a:ext cx="2647188" cy="2926080"/>
+          </a:xfrm>
+          <a:prstGeom prst="roundRect">
+            <a:avLst>
+              <a:gd name="adj" fmla="val 10000"/>
+            </a:avLst>
+          </a:prstGeom>
+          <a:solidFill>
+            <a:srgbClr val="E1E1E1"/>
+          </a:solidFill>
+          <a:ln>
+            <a:noFill/>
+          </a:ln>
+        </p:spPr>
+        <p:txBody>
+          <a:bodyPr wrap="square" lIns="128016" tIns="128016" rIns="128016" bIns="128016" rtlCol="0" anchor="ctr">
+            <a:noAutofit/>
+          </a:bodyPr>
+          <a:lstStyle/>
+          <a:p>
+            <a:pPr algn="ctr">
+              <a:lnSpc>
+                <a:spcPts val="2640"/>
+              </a:lnSpc>
+              <a:spcBef>
+                <a:spcPts val="0"/>
+              </a:spcBef>
+              <a:buNone/>
+            </a:pPr>
+            <a:r>
+              <a:rPr lang="en-US" sz="2200" b="1" dirty="0">
+                <a:solidFill>
+                  <a:srgbClr val="000000"/>
+                </a:solidFill>
+                <a:latin typeface="Outfit Bold"/>
+                <a:ea typeface="Outfit Bold"/>
+                <a:cs typeface="Outfit Bold"/>
+                <a:sym typeface="Outfit Bold"/>
+              </a:rPr>
+              <a:t>Kyverno</a:t>
+            </a:r>
+            <a:endParaRPr lang="en-US" sz="2200" dirty="0"/>
+          </a:p>
+          <a:p>
+            <a:pPr algn="ctr">
+              <a:lnSpc>
+                <a:spcPts val="2040"/>
+              </a:lnSpc>
+              <a:spcBef>
+                <a:spcPts val="200"/>
+              </a:spcBef>
+              <a:buNone/>
+            </a:pPr>
+            <a:r>
+              <a:rPr lang="en-US" sz="1700" dirty="0">
+                <a:solidFill>
+                  <a:srgbClr val="000000"/>
+                </a:solidFill>
+                <a:latin typeface="Outfit"/>
+                <a:ea typeface="Outfit"/>
+                <a:cs typeface="Outfit"/>
+                <a:sym typeface="Outfit"/>
+              </a:rPr>
+              <a:t>admission policy: agent identities cannot write</a:t>
+            </a:r>
+            <a:endParaRPr lang="en-US" sz="1700" dirty="0"/>
+          </a:p>
+        </p:txBody>
+      </p:sp>
+      <p:sp>
+        <p:nvSpPr>
+          <p:cNvPr id="22" name="Box 22"/>
+          <p:cNvSpPr/>
+          <p:nvPr/>
+        </p:nvSpPr>
+        <p:spPr>
+          <a:xfrm>
+            <a:off x="4526280" y="5715000"/>
+            <a:ext cx="2647188" cy="1280160"/>
+          </a:xfrm>
+          <a:prstGeom prst="roundRect">
+            <a:avLst>
+              <a:gd name="adj" fmla="val 10000"/>
+            </a:avLst>
+          </a:prstGeom>
+          <a:solidFill>
+            <a:srgbClr val="00CD8F"/>
+          </a:solidFill>
+          <a:ln>
+            <a:noFill/>
+          </a:ln>
+        </p:spPr>
+        <p:txBody>
+          <a:bodyPr wrap="square" lIns="128016" tIns="128016" rIns="128016" bIns="128016" rtlCol="0" anchor="ctr">
+            <a:noAutofit/>
+          </a:bodyPr>
+          <a:lstStyle/>
+          <a:p>
+            <a:pPr algn="ctr">
+              <a:lnSpc>
+                <a:spcPts val="2640"/>
+              </a:lnSpc>
+              <a:spcBef>
+                <a:spcPts val="0"/>
+              </a:spcBef>
+              <a:buNone/>
+            </a:pPr>
+            <a:r>
+              <a:rPr lang="en-US" sz="2200" b="1" dirty="0">
+                <a:solidFill>
+                  <a:srgbClr val="000000"/>
+                </a:solidFill>
+                <a:latin typeface="Outfit Bold"/>
+                <a:ea typeface="Outfit Bold"/>
+                <a:cs typeface="Outfit Bold"/>
+                <a:sym typeface="Outfit Bold"/>
+              </a:rPr>
+              <a:t>runbook-bot</a:t>
+            </a:r>
+            <a:endParaRPr lang="en-US" sz="2200" dirty="0"/>
+          </a:p>
+          <a:p>
+            <a:pPr algn="ctr">
+              <a:lnSpc>
+                <a:spcPts val="2040"/>
+              </a:lnSpc>
+              <a:spcBef>
+                <a:spcPts val="200"/>
+              </a:spcBef>
+              <a:buNone/>
+            </a:pPr>
+            <a:r>
+              <a:rPr lang="en-US" sz="1700" dirty="0">
+                <a:solidFill>
+                  <a:srgbClr val="000000"/>
+                </a:solidFill>
+                <a:latin typeface="Outfit"/>
+                <a:ea typeface="Outfit"/>
+                <a:cs typeface="Outfit"/>
+                <a:sym typeface="Outfit"/>
+              </a:rPr>
+              <a:t>the only GitHub token</a:t>
+            </a:r>
+            <a:endParaRPr lang="en-US" sz="1700" dirty="0"/>
+          </a:p>
+        </p:txBody>
+      </p:sp>
+      <p:sp>
+        <p:nvSpPr>
+          <p:cNvPr id="23" name="Box 23"/>
+          <p:cNvSpPr/>
+          <p:nvPr/>
+        </p:nvSpPr>
+        <p:spPr>
+          <a:xfrm>
+            <a:off x="7813548" y="5715000"/>
+            <a:ext cx="2647188" cy="1280160"/>
+          </a:xfrm>
+          <a:prstGeom prst="roundRect">
+            <a:avLst>
+              <a:gd name="adj" fmla="val 10000"/>
+            </a:avLst>
+          </a:prstGeom>
+          <a:solidFill>
+            <a:srgbClr val="00CD8F"/>
+          </a:solidFill>
+          <a:ln>
+            <a:noFill/>
+          </a:ln>
+        </p:spPr>
+        <p:txBody>
+          <a:bodyPr wrap="square" lIns="128016" tIns="128016" rIns="128016" bIns="128016" rtlCol="0" anchor="ctr">
+            <a:noAutofit/>
+          </a:bodyPr>
+          <a:lstStyle/>
+          <a:p>
+            <a:pPr algn="ctr">
+              <a:lnSpc>
+                <a:spcPts val="2640"/>
+              </a:lnSpc>
+              <a:spcBef>
+                <a:spcPts val="0"/>
+              </a:spcBef>
+              <a:buNone/>
+            </a:pPr>
+            <a:r>
+              <a:rPr lang="en-US" sz="2200" b="1" dirty="0">
+                <a:solidFill>
+                  <a:srgbClr val="000000"/>
+                </a:solidFill>
+                <a:latin typeface="Outfit Bold"/>
+                <a:ea typeface="Outfit Bold"/>
+                <a:cs typeface="Outfit Bold"/>
+                <a:sym typeface="Outfit Bold"/>
+              </a:rPr>
+              <a:t>Hermes</a:t>
+            </a:r>
+            <a:endParaRPr lang="en-US" sz="2200" dirty="0"/>
+          </a:p>
+          <a:p>
+            <a:pPr algn="ctr">
+              <a:lnSpc>
+                <a:spcPts val="2040"/>
+              </a:lnSpc>
+              <a:spcBef>
+                <a:spcPts val="200"/>
+              </a:spcBef>
+              <a:buNone/>
+            </a:pPr>
+            <a:r>
+              <a:rPr lang="en-US" sz="1700" dirty="0">
+                <a:solidFill>
+                  <a:srgbClr val="000000"/>
+                </a:solidFill>
+                <a:latin typeface="Outfit"/>
+                <a:ea typeface="Outfit"/>
+                <a:cs typeface="Outfit"/>
+                <a:sym typeface="Outfit"/>
+              </a:rPr>
+              <a:t>the triage agent</a:t>
+            </a:r>
+            <a:endParaRPr lang="en-US" sz="1700" dirty="0"/>
+          </a:p>
+        </p:txBody>
+      </p:sp>
+      <p:sp>
+        <p:nvSpPr>
+          <p:cNvPr id="24" name="Box 24"/>
+          <p:cNvSpPr/>
+          <p:nvPr/>
+        </p:nvSpPr>
+        <p:spPr>
+          <a:xfrm>
+            <a:off x="11100816" y="5715000"/>
+            <a:ext cx="2647188" cy="1280160"/>
+          </a:xfrm>
+          <a:prstGeom prst="roundRect">
+            <a:avLst>
+              <a:gd name="adj" fmla="val 10000"/>
+            </a:avLst>
+          </a:prstGeom>
+          <a:solidFill>
+            <a:srgbClr val="00CD8F"/>
+          </a:solidFill>
+          <a:ln>
+            <a:noFill/>
+          </a:ln>
+        </p:spPr>
+        <p:txBody>
+          <a:bodyPr wrap="square" lIns="128016" tIns="128016" rIns="128016" bIns="128016" rtlCol="0" anchor="ctr">
+            <a:noAutofit/>
+          </a:bodyPr>
+          <a:lstStyle/>
+          <a:p>
+            <a:pPr algn="ctr">
+              <a:lnSpc>
+                <a:spcPts val="2640"/>
+              </a:lnSpc>
+              <a:spcBef>
+                <a:spcPts val="0"/>
+              </a:spcBef>
+              <a:buNone/>
+            </a:pPr>
+            <a:r>
+              <a:rPr lang="en-US" sz="2200" b="1" dirty="0">
+                <a:solidFill>
+                  <a:srgbClr val="000000"/>
+                </a:solidFill>
+                <a:latin typeface="Outfit Bold"/>
+                <a:ea typeface="Outfit Bold"/>
+                <a:cs typeface="Outfit Bold"/>
+                <a:sym typeface="Outfit Bold"/>
+              </a:rPr>
+              <a:t>k8s-mcp</a:t>
+            </a:r>
+            <a:endParaRPr lang="en-US" sz="2200" dirty="0"/>
+          </a:p>
+          <a:p>
+            <a:pPr algn="ctr">
+              <a:lnSpc>
+                <a:spcPts val="2040"/>
+              </a:lnSpc>
+              <a:spcBef>
+                <a:spcPts val="200"/>
+              </a:spcBef>
+              <a:buNone/>
+            </a:pPr>
+            <a:r>
+              <a:rPr lang="en-US" sz="1700" dirty="0">
+                <a:solidFill>
+                  <a:srgbClr val="000000"/>
+                </a:solidFill>
+                <a:latin typeface="Outfit"/>
+                <a:ea typeface="Outfit"/>
+                <a:cs typeface="Outfit"/>
+                <a:sym typeface="Outfit"/>
+              </a:rPr>
+              <a:t>read-only Kubernetes tools</a:t>
+            </a:r>
+            <a:endParaRPr lang="en-US" sz="1700" dirty="0"/>
+          </a:p>
+        </p:txBody>
+      </p:sp>
+      <p:sp>
+        <p:nvSpPr>
+          <p:cNvPr id="25" name="Box 25"/>
+          <p:cNvSpPr/>
+          <p:nvPr/>
+        </p:nvSpPr>
+        <p:spPr>
+          <a:xfrm>
+            <a:off x="7813548" y="7360920"/>
+            <a:ext cx="2647188" cy="1280160"/>
+          </a:xfrm>
+          <a:prstGeom prst="roundRect">
+            <a:avLst>
+              <a:gd name="adj" fmla="val 10000"/>
+            </a:avLst>
+          </a:prstGeom>
+          <a:solidFill>
+            <a:srgbClr val="E1E1E1"/>
+          </a:solidFill>
+          <a:ln>
+            <a:noFill/>
+          </a:ln>
+        </p:spPr>
+        <p:txBody>
+          <a:bodyPr wrap="square" lIns="128016" tIns="128016" rIns="128016" bIns="128016" rtlCol="0" anchor="ctr">
+            <a:noAutofit/>
+          </a:bodyPr>
+          <a:lstStyle/>
+          <a:p>
+            <a:pPr algn="ctr">
+              <a:lnSpc>
+                <a:spcPts val="2640"/>
+              </a:lnSpc>
+              <a:spcBef>
+                <a:spcPts val="0"/>
+              </a:spcBef>
+              <a:buNone/>
+            </a:pPr>
+            <a:r>
+              <a:rPr lang="en-US" sz="2200" b="1" dirty="0">
+                <a:solidFill>
+                  <a:srgbClr val="000000"/>
+                </a:solidFill>
+                <a:latin typeface="Outfit Bold"/>
+                <a:ea typeface="Outfit Bold"/>
+                <a:cs typeface="Outfit Bold"/>
+                <a:sym typeface="Outfit Bold"/>
+              </a:rPr>
+              <a:t>LiteLLM</a:t>
+            </a:r>
+            <a:endParaRPr lang="en-US" sz="2200" dirty="0"/>
+          </a:p>
+          <a:p>
+            <a:pPr algn="ctr">
+              <a:lnSpc>
+                <a:spcPts val="2040"/>
+              </a:lnSpc>
+              <a:spcBef>
+                <a:spcPts val="200"/>
+              </a:spcBef>
+              <a:buNone/>
+            </a:pPr>
+            <a:r>
+              <a:rPr lang="en-US" sz="1700" dirty="0">
+                <a:solidFill>
+                  <a:srgbClr val="000000"/>
+                </a:solidFill>
+                <a:latin typeface="Outfit"/>
+                <a:ea typeface="Outfit"/>
+                <a:cs typeface="Outfit"/>
+                <a:sym typeface="Outfit"/>
+              </a:rPr>
+              <a:t>AI gateway: keys and budgets</a:t>
+            </a:r>
+            <a:endParaRPr lang="en-US" sz="1700" dirty="0"/>
+          </a:p>
+        </p:txBody>
+      </p:sp>
+      <p:sp>
+        <p:nvSpPr>
+          <p:cNvPr id="26" name="Box 26"/>
+          <p:cNvSpPr/>
+          <p:nvPr/>
+        </p:nvSpPr>
+        <p:spPr>
+          <a:xfrm>
+            <a:off x="11100816" y="7360920"/>
+            <a:ext cx="2647188" cy="1280160"/>
+          </a:xfrm>
+          <a:prstGeom prst="roundRect">
+            <a:avLst>
+              <a:gd name="adj" fmla="val 10000"/>
+            </a:avLst>
+          </a:prstGeom>
+          <a:solidFill>
+            <a:srgbClr val="E1E1E1"/>
+          </a:solidFill>
+          <a:ln>
+            <a:noFill/>
+          </a:ln>
+        </p:spPr>
+        <p:txBody>
+          <a:bodyPr wrap="square" lIns="128016" tIns="128016" rIns="128016" bIns="128016" rtlCol="0" anchor="ctr">
+            <a:noAutofit/>
+          </a:bodyPr>
+          <a:lstStyle/>
+          <a:p>
+            <a:pPr algn="ctr">
+              <a:lnSpc>
+                <a:spcPts val="2640"/>
+              </a:lnSpc>
+              <a:spcBef>
+                <a:spcPts val="0"/>
+              </a:spcBef>
+              <a:buNone/>
+            </a:pPr>
+            <a:r>
+              <a:rPr lang="en-US" sz="2200" b="1" dirty="0">
+                <a:solidFill>
+                  <a:srgbClr val="000000"/>
+                </a:solidFill>
+                <a:latin typeface="Outfit Bold"/>
+                <a:ea typeface="Outfit Bold"/>
+                <a:cs typeface="Outfit Bold"/>
+                <a:sym typeface="Outfit Bold"/>
+              </a:rPr>
+              <a:t>Langfuse</a:t>
+            </a:r>
+            <a:endParaRPr lang="en-US" sz="2200" dirty="0"/>
+          </a:p>
+          <a:p>
+            <a:pPr algn="ctr">
+              <a:lnSpc>
+                <a:spcPts val="2040"/>
+              </a:lnSpc>
+              <a:spcBef>
+                <a:spcPts val="200"/>
+              </a:spcBef>
+              <a:buNone/>
+            </a:pPr>
+            <a:r>
+              <a:rPr lang="en-US" sz="1700" dirty="0">
+                <a:solidFill>
+                  <a:srgbClr val="000000"/>
+                </a:solidFill>
+                <a:latin typeface="Outfit"/>
+                <a:ea typeface="Outfit"/>
+                <a:cs typeface="Outfit"/>
+                <a:sym typeface="Outfit"/>
+              </a:rPr>
+              <a:t>traces, tokens, and cost</a:t>
+            </a:r>
+            <a:endParaRPr lang="en-US" sz="1700" dirty="0"/>
+          </a:p>
+        </p:txBody>
+      </p:sp>
+      <p:sp>
+        <p:nvSpPr>
+          <p:cNvPr id="27" name="Text 27"/>
+          <p:cNvSpPr txBox="1"/>
+          <p:nvPr/>
+        </p:nvSpPr>
+        <p:spPr>
+          <a:xfrm>
+            <a:off x="14388084" y="7589520"/>
+            <a:ext cx="2647188" cy="914400"/>
+          </a:xfrm>
+          <a:prstGeom prst="rect">
+            <a:avLst/>
+          </a:prstGeom>
+          <a:noFill/>
+        </p:spPr>
+        <p:txBody>
+          <a:bodyPr wrap="square" lIns="0" tIns="0" rIns="0" bIns="0" rtlCol="0" anchor="t">
+            <a:noAutofit/>
+          </a:bodyPr>
+          <a:lstStyle/>
+          <a:p>
+            <a:pPr algn="l">
+              <a:lnSpc>
+                <a:spcPts val="2380"/>
+              </a:lnSpc>
+              <a:spcBef>
+                <a:spcPts val="0"/>
+              </a:spcBef>
+              <a:buNone/>
+            </a:pPr>
+            <a:r>
+              <a:rPr lang="en-US" sz="1700" dirty="0">
+                <a:solidFill>
+                  <a:srgbClr val="595959"/>
+                </a:solidFill>
+                <a:latin typeface="Outfit"/>
+                <a:ea typeface="Outfit"/>
+                <a:cs typeface="Outfit"/>
+                <a:sym typeface="Outfit"/>
+              </a:rPr>
+              <a:t>Green: the agent and its helpers, in the agents namespace.</a:t>
+            </a:r>
+            <a:endParaRPr lang="en-US" sz="1700" dirty="0"/>
+          </a:p>
+        </p:txBody>
+      </p:sp>
+      <p:cxnSp>
+        <p:nvCxnSpPr>
+          <p:cNvPr id="28" name="Arrow 28"/>
+          <p:cNvCxnSpPr/>
+          <p:nvPr/>
+        </p:nvCxnSpPr>
+        <p:spPr>
+          <a:xfrm>
+            <a:off x="3858768" y="3268980"/>
+            <a:ext cx="667512" cy="0"/>
+          </a:xfrm>
+          <a:prstGeom prst="straightConnector1">
+            <a:avLst/>
+          </a:prstGeom>
+          <a:ln w="28575">
+            <a:solidFill>
+              <a:srgbClr val="000000"/>
+            </a:solidFill>
+            <a:tailEnd type="triangle" w="med" len="med"/>
+          </a:ln>
+        </p:spPr>
+      </p:cxnSp>
+      <p:cxnSp>
+        <p:nvCxnSpPr>
+          <p:cNvPr id="29" name="Arrow 29"/>
+          <p:cNvCxnSpPr/>
+          <p:nvPr/>
+        </p:nvCxnSpPr>
+        <p:spPr>
+          <a:xfrm>
+            <a:off x="3858768" y="4709160"/>
+            <a:ext cx="667512" cy="0"/>
+          </a:xfrm>
+          <a:prstGeom prst="straightConnector1">
+            <a:avLst/>
+          </a:prstGeom>
+          <a:ln w="28575">
+            <a:solidFill>
+              <a:srgbClr val="000000"/>
+            </a:solidFill>
+            <a:tailEnd type="triangle" w="med" len="med"/>
+          </a:ln>
+        </p:spPr>
+      </p:cxnSp>
+      <p:cxnSp>
+        <p:nvCxnSpPr>
+          <p:cNvPr id="30" name="Arrow 30"/>
+          <p:cNvCxnSpPr/>
+          <p:nvPr/>
+        </p:nvCxnSpPr>
+        <p:spPr>
+          <a:xfrm flipH="1">
+            <a:off x="3858768" y="6355080"/>
+            <a:ext cx="667512" cy="0"/>
+          </a:xfrm>
+          <a:prstGeom prst="straightConnector1">
+            <a:avLst/>
+          </a:prstGeom>
+          <a:ln w="28575">
+            <a:solidFill>
+              <a:srgbClr val="000000"/>
+            </a:solidFill>
+            <a:tailEnd type="triangle" w="med" len="med"/>
+          </a:ln>
+        </p:spPr>
+      </p:cxnSp>
+      <p:cxnSp>
+        <p:nvCxnSpPr>
+          <p:cNvPr id="31" name="Arrow 31"/>
+          <p:cNvCxnSpPr/>
+          <p:nvPr/>
+        </p:nvCxnSpPr>
+        <p:spPr>
+          <a:xfrm>
+            <a:off x="9137142" y="5349240"/>
+            <a:ext cx="0" cy="365760"/>
+          </a:xfrm>
+          <a:prstGeom prst="straightConnector1">
+            <a:avLst/>
+          </a:prstGeom>
+          <a:ln w="28575">
+            <a:solidFill>
+              <a:srgbClr val="000000"/>
+            </a:solidFill>
+            <a:tailEnd type="triangle" w="med" len="med"/>
+          </a:ln>
+        </p:spPr>
+      </p:cxnSp>
+      <p:sp>
+        <p:nvSpPr>
+          <p:cNvPr id="32" name="Text 32"/>
+          <p:cNvSpPr txBox="1"/>
+          <p:nvPr/>
+        </p:nvSpPr>
+        <p:spPr>
+          <a:xfrm>
+            <a:off x="9246870" y="5367528"/>
+            <a:ext cx="2011680" cy="365760"/>
+          </a:xfrm>
+          <a:prstGeom prst="rect">
+            <a:avLst/>
+          </a:prstGeom>
+          <a:noFill/>
+        </p:spPr>
+        <p:txBody>
+          <a:bodyPr wrap="square" lIns="0" tIns="0" rIns="0" bIns="0" rtlCol="0" anchor="t">
+            <a:noAutofit/>
+          </a:bodyPr>
+          <a:lstStyle/>
+          <a:p>
+            <a:pPr algn="l">
+              <a:lnSpc>
+                <a:spcPts val="1920"/>
+              </a:lnSpc>
+              <a:spcBef>
+                <a:spcPts val="0"/>
+              </a:spcBef>
+              <a:buNone/>
+            </a:pPr>
+            <a:r>
+              <a:rPr lang="en-US" sz="1600" dirty="0">
+                <a:solidFill>
+                  <a:srgbClr val="595959"/>
+                </a:solidFill>
+                <a:latin typeface="Outfit"/>
+                <a:ea typeface="Outfit"/>
+                <a:cs typeface="Outfit"/>
+                <a:sym typeface="Outfit"/>
+              </a:rPr>
+              <a:t>alert</a:t>
+            </a:r>
+            <a:endParaRPr lang="en-US" sz="1600" dirty="0"/>
+          </a:p>
+        </p:txBody>
+      </p:sp>
+      <p:cxnSp>
+        <p:nvCxnSpPr>
+          <p:cNvPr id="33" name="Arrow 33"/>
+          <p:cNvCxnSpPr/>
+          <p:nvPr/>
+        </p:nvCxnSpPr>
+        <p:spPr>
+          <a:xfrm flipH="1">
+            <a:off x="7173468" y="6355080"/>
+            <a:ext cx="640080" cy="0"/>
+          </a:xfrm>
+          <a:prstGeom prst="straightConnector1">
+            <a:avLst/>
+          </a:prstGeom>
+          <a:ln w="28575">
+            <a:solidFill>
+              <a:srgbClr val="000000"/>
+            </a:solidFill>
+            <a:tailEnd type="triangle" w="med" len="med"/>
+          </a:ln>
+        </p:spPr>
+      </p:cxnSp>
+      <p:sp>
+        <p:nvSpPr>
+          <p:cNvPr id="34" name="Text 34"/>
+          <p:cNvSpPr txBox="1"/>
+          <p:nvPr/>
+        </p:nvSpPr>
+        <p:spPr>
+          <a:xfrm>
+            <a:off x="7200900" y="5943600"/>
+            <a:ext cx="2011680" cy="365760"/>
+          </a:xfrm>
+          <a:prstGeom prst="rect">
+            <a:avLst/>
+          </a:prstGeom>
+          <a:noFill/>
+        </p:spPr>
+        <p:txBody>
+          <a:bodyPr wrap="square" lIns="0" tIns="0" rIns="0" bIns="0" rtlCol="0" anchor="t">
+            <a:noAutofit/>
+          </a:bodyPr>
+          <a:lstStyle/>
+          <a:p>
+            <a:pPr algn="l">
+              <a:lnSpc>
+                <a:spcPts val="1920"/>
+              </a:lnSpc>
+              <a:spcBef>
+                <a:spcPts val="0"/>
+              </a:spcBef>
+              <a:buNone/>
+            </a:pPr>
+            <a:r>
+              <a:rPr lang="en-US" sz="1600" dirty="0">
+                <a:solidFill>
+                  <a:srgbClr val="595959"/>
+                </a:solidFill>
+                <a:latin typeface="Outfit"/>
+                <a:ea typeface="Outfit"/>
+                <a:cs typeface="Outfit"/>
+                <a:sym typeface="Outfit"/>
+              </a:rPr>
+              <a:t>report</a:t>
+            </a:r>
+            <a:endParaRPr lang="en-US" sz="1600" dirty="0"/>
+          </a:p>
+        </p:txBody>
+      </p:sp>
+      <p:cxnSp>
+        <p:nvCxnSpPr>
+          <p:cNvPr id="35" name="Arrow 35"/>
+          <p:cNvCxnSpPr/>
+          <p:nvPr/>
+        </p:nvCxnSpPr>
+        <p:spPr>
+          <a:xfrm>
+            <a:off x="10460736" y="6355080"/>
+            <a:ext cx="640080" cy="0"/>
+          </a:xfrm>
+          <a:prstGeom prst="straightConnector1">
+            <a:avLst/>
+          </a:prstGeom>
+          <a:ln w="28575">
+            <a:solidFill>
+              <a:srgbClr val="000000"/>
+            </a:solidFill>
+            <a:tailEnd type="triangle" w="med" len="med"/>
+          </a:ln>
+        </p:spPr>
+      </p:cxnSp>
+      <p:sp>
+        <p:nvSpPr>
+          <p:cNvPr id="36" name="Text 36"/>
+          <p:cNvSpPr txBox="1"/>
+          <p:nvPr/>
+        </p:nvSpPr>
+        <p:spPr>
+          <a:xfrm>
+            <a:off x="10570464" y="5943600"/>
+            <a:ext cx="2011680" cy="365760"/>
+          </a:xfrm>
+          <a:prstGeom prst="rect">
+            <a:avLst/>
+          </a:prstGeom>
+          <a:noFill/>
+        </p:spPr>
+        <p:txBody>
+          <a:bodyPr wrap="square" lIns="0" tIns="0" rIns="0" bIns="0" rtlCol="0" anchor="t">
+            <a:noAutofit/>
+          </a:bodyPr>
+          <a:lstStyle/>
+          <a:p>
+            <a:pPr algn="l">
+              <a:lnSpc>
+                <a:spcPts val="1920"/>
+              </a:lnSpc>
+              <a:spcBef>
+                <a:spcPts val="0"/>
+              </a:spcBef>
+              <a:buNone/>
+            </a:pPr>
+            <a:r>
+              <a:rPr lang="en-US" sz="1600" dirty="0">
+                <a:solidFill>
+                  <a:srgbClr val="595959"/>
+                </a:solidFill>
+                <a:latin typeface="Outfit"/>
+                <a:ea typeface="Outfit"/>
+                <a:cs typeface="Outfit"/>
+                <a:sym typeface="Outfit"/>
+              </a:rPr>
+              <a:t>MCP</a:t>
+            </a:r>
+            <a:endParaRPr lang="en-US" sz="1600" dirty="0"/>
+          </a:p>
+        </p:txBody>
+      </p:sp>
+      <p:cxnSp>
+        <p:nvCxnSpPr>
+          <p:cNvPr id="37" name="Arrow 37"/>
+          <p:cNvCxnSpPr/>
+          <p:nvPr/>
+        </p:nvCxnSpPr>
+        <p:spPr>
+          <a:xfrm flipV="1">
+            <a:off x="12424410" y="5349240"/>
+            <a:ext cx="0" cy="365760"/>
+          </a:xfrm>
+          <a:prstGeom prst="straightConnector1">
+            <a:avLst/>
+          </a:prstGeom>
+          <a:ln w="28575">
+            <a:solidFill>
+              <a:srgbClr val="000000"/>
+            </a:solidFill>
+            <a:tailEnd type="triangle" w="med" len="med"/>
+          </a:ln>
+        </p:spPr>
+      </p:cxnSp>
+      <p:sp>
+        <p:nvSpPr>
+          <p:cNvPr id="38" name="Text 38"/>
+          <p:cNvSpPr txBox="1"/>
+          <p:nvPr/>
+        </p:nvSpPr>
+        <p:spPr>
+          <a:xfrm>
+            <a:off x="12534138" y="5367528"/>
+            <a:ext cx="2011680" cy="365760"/>
+          </a:xfrm>
+          <a:prstGeom prst="rect">
+            <a:avLst/>
+          </a:prstGeom>
+          <a:noFill/>
+        </p:spPr>
+        <p:txBody>
+          <a:bodyPr wrap="square" lIns="0" tIns="0" rIns="0" bIns="0" rtlCol="0" anchor="t">
+            <a:noAutofit/>
+          </a:bodyPr>
+          <a:lstStyle/>
+          <a:p>
+            <a:pPr algn="l">
+              <a:lnSpc>
+                <a:spcPts val="1920"/>
+              </a:lnSpc>
+              <a:spcBef>
+                <a:spcPts val="0"/>
+              </a:spcBef>
+              <a:buNone/>
+            </a:pPr>
+            <a:r>
+              <a:rPr lang="en-US" sz="1600" dirty="0">
+                <a:solidFill>
+                  <a:srgbClr val="595959"/>
+                </a:solidFill>
+                <a:latin typeface="Outfit"/>
+                <a:ea typeface="Outfit"/>
+                <a:cs typeface="Outfit"/>
+                <a:sym typeface="Outfit"/>
+              </a:rPr>
+              <a:t>reads</a:t>
+            </a:r>
+            <a:endParaRPr lang="en-US" sz="1600" dirty="0"/>
+          </a:p>
+        </p:txBody>
+      </p:sp>
+      <p:cxnSp>
+        <p:nvCxnSpPr>
+          <p:cNvPr id="39" name="Arrow 39"/>
+          <p:cNvCxnSpPr/>
+          <p:nvPr/>
+        </p:nvCxnSpPr>
+        <p:spPr>
+          <a:xfrm>
+            <a:off x="9137142" y="6995160"/>
+            <a:ext cx="0" cy="365760"/>
+          </a:xfrm>
+          <a:prstGeom prst="straightConnector1">
+            <a:avLst/>
+          </a:prstGeom>
+          <a:ln w="28575">
+            <a:solidFill>
+              <a:srgbClr val="000000"/>
+            </a:solidFill>
+            <a:tailEnd type="triangle" w="med" len="med"/>
+          </a:ln>
+        </p:spPr>
+      </p:cxnSp>
+      <p:sp>
+        <p:nvSpPr>
+          <p:cNvPr id="40" name="Text 40"/>
+          <p:cNvSpPr txBox="1"/>
+          <p:nvPr/>
+        </p:nvSpPr>
+        <p:spPr>
+          <a:xfrm>
+            <a:off x="9246870" y="7013448"/>
+            <a:ext cx="2011680" cy="365760"/>
+          </a:xfrm>
+          <a:prstGeom prst="rect">
+            <a:avLst/>
+          </a:prstGeom>
+          <a:noFill/>
+        </p:spPr>
+        <p:txBody>
+          <a:bodyPr wrap="square" lIns="0" tIns="0" rIns="0" bIns="0" rtlCol="0" anchor="t">
+            <a:noAutofit/>
+          </a:bodyPr>
+          <a:lstStyle/>
+          <a:p>
+            <a:pPr algn="l">
+              <a:lnSpc>
+                <a:spcPts val="1920"/>
+              </a:lnSpc>
+              <a:spcBef>
+                <a:spcPts val="0"/>
+              </a:spcBef>
+              <a:buNone/>
+            </a:pPr>
+            <a:r>
+              <a:rPr lang="en-US" sz="1600" dirty="0">
+                <a:solidFill>
+                  <a:srgbClr val="595959"/>
+                </a:solidFill>
+                <a:latin typeface="Outfit"/>
+                <a:ea typeface="Outfit"/>
+                <a:cs typeface="Outfit"/>
+                <a:sym typeface="Outfit"/>
+              </a:rPr>
+              <a:t>virtual key</a:t>
+            </a:r>
+            <a:endParaRPr lang="en-US" sz="1600" dirty="0"/>
+          </a:p>
+        </p:txBody>
+      </p:sp>
+      <p:cxnSp>
+        <p:nvCxnSpPr>
+          <p:cNvPr id="41" name="Arrow 41"/>
+          <p:cNvCxnSpPr/>
+          <p:nvPr/>
+        </p:nvCxnSpPr>
+        <p:spPr>
+          <a:xfrm>
+            <a:off x="10460736" y="8001000"/>
+            <a:ext cx="640080" cy="0"/>
+          </a:xfrm>
+          <a:prstGeom prst="straightConnector1">
+            <a:avLst/>
+          </a:prstGeom>
+          <a:ln w="28575">
+            <a:solidFill>
+              <a:srgbClr val="000000"/>
+            </a:solidFill>
+            <a:tailEnd type="triangle" w="med" len="med"/>
+          </a:ln>
+        </p:spPr>
+      </p:cxnSp>
+      <p:sp>
+        <p:nvSpPr>
+          <p:cNvPr id="42" name="Text 42"/>
+          <p:cNvSpPr txBox="1"/>
+          <p:nvPr/>
+        </p:nvSpPr>
+        <p:spPr>
+          <a:xfrm>
+            <a:off x="10488168" y="7589520"/>
+            <a:ext cx="2011680" cy="365760"/>
+          </a:xfrm>
+          <a:prstGeom prst="rect">
+            <a:avLst/>
+          </a:prstGeom>
+          <a:noFill/>
+        </p:spPr>
+        <p:txBody>
+          <a:bodyPr wrap="square" lIns="0" tIns="0" rIns="0" bIns="0" rtlCol="0" anchor="t">
+            <a:noAutofit/>
+          </a:bodyPr>
+          <a:lstStyle/>
+          <a:p>
+            <a:pPr algn="l">
+              <a:lnSpc>
+                <a:spcPts val="1920"/>
+              </a:lnSpc>
+              <a:spcBef>
+                <a:spcPts val="0"/>
+              </a:spcBef>
+              <a:buNone/>
+            </a:pPr>
+            <a:r>
+              <a:rPr lang="en-US" sz="1600" dirty="0">
+                <a:solidFill>
+                  <a:srgbClr val="595959"/>
+                </a:solidFill>
+                <a:latin typeface="Outfit"/>
+                <a:ea typeface="Outfit"/>
+                <a:cs typeface="Outfit"/>
+                <a:sym typeface="Outfit"/>
+              </a:rPr>
+              <a:t>traces</a:t>
+            </a:r>
+            <a:endParaRPr lang="en-US" sz="1600" dirty="0"/>
+          </a:p>
+        </p:txBody>
+      </p:sp>
+      <p:cxnSp>
+        <p:nvCxnSpPr>
+          <p:cNvPr id="43" name="Arrow 43"/>
+          <p:cNvCxnSpPr/>
+          <p:nvPr/>
+        </p:nvCxnSpPr>
+        <p:spPr>
+          <a:xfrm flipH="1">
+            <a:off x="3858768" y="8001000"/>
+            <a:ext cx="3954780" cy="0"/>
+          </a:xfrm>
+          <a:prstGeom prst="straightConnector1">
+            <a:avLst/>
+          </a:prstGeom>
+          <a:ln w="28575">
+            <a:solidFill>
+              <a:srgbClr val="000000"/>
+            </a:solidFill>
+            <a:tailEnd type="triangle" w="med" len="med"/>
+          </a:ln>
+        </p:spPr>
+      </p:cxnSp>
+      <p:sp>
+        <p:nvSpPr>
+          <p:cNvPr id="44" name="Text 44"/>
+          <p:cNvSpPr txBox="1"/>
+          <p:nvPr/>
+        </p:nvSpPr>
+        <p:spPr>
+          <a:xfrm>
+            <a:off x="4800600" y="7635240"/>
+            <a:ext cx="2011680" cy="365760"/>
+          </a:xfrm>
+          <a:prstGeom prst="rect">
+            <a:avLst/>
+          </a:prstGeom>
+          <a:noFill/>
+        </p:spPr>
+        <p:txBody>
+          <a:bodyPr wrap="square" lIns="0" tIns="0" rIns="0" bIns="0" rtlCol="0" anchor="t">
+            <a:noAutofit/>
+          </a:bodyPr>
+          <a:lstStyle/>
+          <a:p>
+            <a:pPr algn="l">
+              <a:lnSpc>
+                <a:spcPts val="1920"/>
+              </a:lnSpc>
+              <a:spcBef>
+                <a:spcPts val="0"/>
+              </a:spcBef>
+              <a:buNone/>
+            </a:pPr>
+            <a:r>
+              <a:rPr lang="en-US" sz="1600" dirty="0">
+                <a:solidFill>
+                  <a:srgbClr val="595959"/>
+                </a:solidFill>
+                <a:latin typeface="Outfit"/>
+                <a:ea typeface="Outfit"/>
+                <a:cs typeface="Outfit"/>
+                <a:sym typeface="Outfit"/>
+              </a:rPr>
+              <a:t>provider key</a:t>
+            </a:r>
+            <a:endParaRPr lang="en-US" sz="1600" dirty="0"/>
+          </a:p>
+        </p:txBody>
+      </p:sp>
+    </p:spTree>
+  </p:cSld>
+  <p:clrMapOvr>
+    <a:masterClrMapping/>
+  </p:clrMapOvr>
+</p:sld>
+</file>
+
+<file path=ppt/slides/slide46.xml><?xml version="1.0" encoding="utf-8"?>
+<p:sld xmlns:a="http://schemas.openxmlformats.org/drawingml/2006/main" xmlns:p="http://schemas.openxmlformats.org/presentationml/2006/main" xmlns:r="http://schemas.openxmlformats.org/officeDocument/2006/relationships">
+  <p:cSld>
+    <p:spTree>
+      <p:nvGrpSpPr>
+        <p:cNvPr id="1" name=""/>
+        <p:cNvGrpSpPr/>
+        <p:nvPr/>
+      </p:nvGrpSpPr>
+      <p:grpSpPr/>
+      <p:sp>
+        <p:nvSpPr>
+          <p:cNvPr id="2" name="AutoShape 2"/>
+          <p:cNvSpPr/>
+          <p:nvPr/>
+        </p:nvSpPr>
+        <p:spPr>
+          <a:xfrm>
+            <a:off x="1028700" y="1028700"/>
+            <a:ext cx="16230600" cy="0"/>
+          </a:xfrm>
+          <a:prstGeom prst="line">
+            <a:avLst/>
+          </a:prstGeom>
+          <a:ln w="38100" cap="flat">
+            <a:solidFill>
+              <a:srgbClr val="000000"/>
+            </a:solidFill>
+            <a:prstDash val="solid"/>
+            <a:headEnd type="none" w="sm" len="sm"/>
+            <a:tailEnd type="none" w="sm" len="sm"/>
+          </a:ln>
+        </p:spPr>
+        <p:txBody>
+          <a:bodyPr/>
+          <a:lstStyle/>
+          <a:p>
+            <a:endParaRPr lang="en-US"/>
+          </a:p>
+        </p:txBody>
+      </p:sp>
+      <p:sp>
+        <p:nvSpPr>
+          <p:cNvPr id="3" name="AutoShape 3"/>
+          <p:cNvSpPr/>
+          <p:nvPr/>
+        </p:nvSpPr>
+        <p:spPr>
+          <a:xfrm>
+            <a:off x="1028700" y="9277350"/>
+            <a:ext cx="16230600" cy="0"/>
+          </a:xfrm>
+          <a:prstGeom prst="line">
+            <a:avLst/>
+          </a:prstGeom>
+          <a:ln w="38100" cap="flat">
+            <a:solidFill>
+              <a:srgbClr val="000000"/>
+            </a:solidFill>
+            <a:prstDash val="solid"/>
+            <a:headEnd type="none" w="sm" len="sm"/>
+            <a:tailEnd type="none" w="sm" len="sm"/>
+          </a:ln>
+        </p:spPr>
+        <p:txBody>
+          <a:bodyPr/>
+          <a:lstStyle/>
+          <a:p>
+            <a:endParaRPr lang="en-US"/>
+          </a:p>
+        </p:txBody>
+      </p:sp>
+      <p:sp>
+        <p:nvSpPr>
+          <p:cNvPr id="4" name="TextBox 4"/>
+          <p:cNvSpPr txBox="1"/>
+          <p:nvPr/>
+        </p:nvSpPr>
+        <p:spPr>
+          <a:xfrm>
+            <a:off x="1024128" y="1461010"/>
+            <a:ext cx="15087600" cy="863600"/>
+          </a:xfrm>
+          <a:prstGeom prst="rect">
+            <a:avLst/>
+          </a:prstGeom>
+        </p:spPr>
+        <p:txBody>
+          <a:bodyPr lIns="0" tIns="0" rIns="0" bIns="0" rtlCol="0" anchor="t" wrap="square">
+            <a:spAutoFit/>
+          </a:bodyPr>
+          <a:lstStyle/>
+          <a:p>
+            <a:pPr algn="l">
+              <a:lnSpc>
+                <a:spcPts val="7000"/>
+              </a:lnSpc>
+              <a:spcBef>
+                <a:spcPts val="0"/>
+              </a:spcBef>
+              <a:buNone/>
+            </a:pPr>
+            <a:r>
+              <a:rPr lang="en-US" sz="5000" b="1" dirty="0">
+                <a:solidFill>
+                  <a:srgbClr val="000000"/>
+                </a:solidFill>
+                <a:latin typeface="Outfit Bold"/>
+                <a:ea typeface="Outfit Bold"/>
+                <a:cs typeface="Outfit Bold"/>
+                <a:sym typeface="Outfit Bold"/>
+              </a:rPr>
+              <a:t>How the labs fit together</a:t>
+            </a:r>
+            <a:endParaRPr lang="en-US" sz="5000" dirty="0"/>
+          </a:p>
+        </p:txBody>
+      </p:sp>
+      <p:sp>
+        <p:nvSpPr>
+          <p:cNvPr id="5" name="TextBox 5"/>
+          <p:cNvSpPr txBox="1"/>
+          <p:nvPr/>
+        </p:nvSpPr>
+        <p:spPr>
+          <a:xfrm>
+            <a:off x="16882846" y="9172575"/>
+            <a:ext cx="376454" cy="896620"/>
+          </a:xfrm>
+          <a:prstGeom prst="rect">
+            <a:avLst/>
+          </a:prstGeom>
+        </p:spPr>
+        <p:txBody>
+          <a:bodyPr lIns="0" tIns="0" rIns="0" bIns="0" rtlCol="0" anchor="t">
+            <a:spAutoFit/>
+          </a:bodyPr>
+          <a:lstStyle/>
+          <a:p>
+            <a:pPr algn="ctr">
+              <a:lnSpc>
+                <a:spcPts val="7279"/>
+              </a:lnSpc>
+            </a:pPr>
+            <a:r>
+              <a:rPr lang="en-US" sz="5199" b="1">
+                <a:solidFill>
+                  <a:srgbClr val="F97141"/>
+                </a:solidFill>
+                <a:latin typeface="Outfit Bold"/>
+                <a:ea typeface="Outfit Bold"/>
+                <a:cs typeface="Outfit Bold"/>
+                <a:sym typeface="Outfit Bold"/>
+              </a:rPr>
+              <a:t>&gt;</a:t>
+            </a:r>
+          </a:p>
+        </p:txBody>
+      </p:sp>
+      <p:sp>
+        <p:nvSpPr>
+          <p:cNvPr id="6" name="TextBox 6"/>
+          <p:cNvSpPr txBox="1"/>
+          <p:nvPr/>
+        </p:nvSpPr>
+        <p:spPr>
+          <a:xfrm>
+            <a:off x="1256705" y="9549448"/>
+            <a:ext cx="1463040" cy="418956"/>
+          </a:xfrm>
+          <a:prstGeom prst="rect">
+            <a:avLst/>
+          </a:prstGeom>
+        </p:spPr>
+        <p:txBody>
+          <a:bodyPr wrap="square" lIns="0" tIns="0" rIns="0" bIns="0" rtlCol="0" anchor="t">
+            <a:spAutoFit/>
+          </a:bodyPr>
+          <a:lstStyle/>
+          <a:p>
+            <a:pPr algn="l">
+              <a:lnSpc>
+                <a:spcPts val="3360"/>
+              </a:lnSpc>
+              <a:spcBef>
+                <a:spcPts val="0"/>
+              </a:spcBef>
+              <a:buNone/>
+            </a:pPr>
+            <a:r>
+              <a:rPr lang="en-US" sz="2400" dirty="0">
+                <a:solidFill>
+                  <a:srgbClr val="000000"/>
+                </a:solidFill>
+                <a:latin typeface="Outfit"/>
+                <a:ea typeface="Outfit"/>
+                <a:cs typeface="Outfit"/>
+                <a:sym typeface="Outfit"/>
+              </a:rPr>
+              <a:t>Pg: 12</a:t>
             </a:r>
             <a:endParaRPr lang="en-US" sz="2400" dirty="0"/>
           </a:p>
@@ -16479,7 +19043,7 @@
 </p:sld>
 </file>
 
-<file path=ppt/slides/slide46.xml><?xml version="1.0" encoding="utf-8"?>
+<file path=ppt/slides/slide47.xml><?xml version="1.0" encoding="utf-8"?>
 <p:sld xmlns:a="http://schemas.openxmlformats.org/drawingml/2006/main" xmlns:p="http://schemas.openxmlformats.org/presentationml/2006/main" xmlns:r="http://schemas.openxmlformats.org/officeDocument/2006/relationships">
   <p:cSld>
     <p:spTree>
@@ -16757,7 +19321,7 @@
 </p:sld>
 </file>
 
-<file path=ppt/slides/slide47.xml><?xml version="1.0" encoding="utf-8"?>
+<file path=ppt/slides/slide48.xml><?xml version="1.0" encoding="utf-8"?>
 <p:sld xmlns:a="http://schemas.openxmlformats.org/drawingml/2006/main" xmlns:p="http://schemas.openxmlformats.org/presentationml/2006/main" xmlns:r="http://schemas.openxmlformats.org/officeDocument/2006/relationships">
   <p:cSld>
     <p:bg>
@@ -17222,7 +19786,7 @@
 </p:sld>
 </file>
 
-<file path=ppt/slides/slide48.xml><?xml version="1.0" encoding="utf-8"?>
+<file path=ppt/slides/slide49.xml><?xml version="1.0" encoding="utf-8"?>
 <p:sld xmlns:a="http://schemas.openxmlformats.org/drawingml/2006/main" xmlns:p="http://schemas.openxmlformats.org/presentationml/2006/main" xmlns:r="http://schemas.openxmlformats.org/officeDocument/2006/relationships">
   <p:cSld>
     <p:spTree>
@@ -17663,7 +20227,7 @@
                 <a:cs typeface="Outfit"/>
                 <a:sym typeface="Outfit"/>
               </a:rPr>
-              <a:t>Pg: 14</a:t>
+              <a:t>Pg: 15</a:t>
             </a:r>
             <a:endParaRPr lang="en-US" sz="2400" dirty="0"/>
           </a:p>
@@ -18041,7 +20605,7 @@
 </p:sld>
 </file>
 
-<file path=ppt/slides/slide49.xml><?xml version="1.0" encoding="utf-8"?>
+<file path=ppt/slides/slide50.xml><?xml version="1.0" encoding="utf-8"?>
 <p:sld xmlns:a="http://schemas.openxmlformats.org/drawingml/2006/main" xmlns:p="http://schemas.openxmlformats.org/presentationml/2006/main" xmlns:r="http://schemas.openxmlformats.org/officeDocument/2006/relationships">
   <p:cSld>
     <p:spTree>
@@ -18525,7 +21089,7 @@
                 <a:cs typeface="Outfit"/>
                 <a:sym typeface="Outfit"/>
               </a:rPr>
-              <a:t>Pg: 15</a:t>
+              <a:t>Pg: 16</a:t>
             </a:r>
             <a:endParaRPr lang="en-US" sz="2400" dirty="0"/>
           </a:p>
@@ -18995,7 +21559,7 @@
 </p:sld>
 </file>
 
-<file path=ppt/slides/slide50.xml><?xml version="1.0" encoding="utf-8"?>
+<file path=ppt/slides/slide51.xml><?xml version="1.0" encoding="utf-8"?>
 <p:sld xmlns:a="http://schemas.openxmlformats.org/drawingml/2006/main" xmlns:p="http://schemas.openxmlformats.org/presentationml/2006/main" xmlns:r="http://schemas.openxmlformats.org/officeDocument/2006/relationships">
   <p:cSld>
     <p:spTree>
@@ -19273,7 +21837,7 @@
 </p:sld>
 </file>
 
-<file path=ppt/slides/slide51.xml><?xml version="1.0" encoding="utf-8"?>
+<file path=ppt/slides/slide52.xml><?xml version="1.0" encoding="utf-8"?>
 <p:sld xmlns:a="http://schemas.openxmlformats.org/drawingml/2006/main" xmlns:p="http://schemas.openxmlformats.org/presentationml/2006/main" xmlns:r="http://schemas.openxmlformats.org/officeDocument/2006/relationships">
   <p:cSld>
     <p:spTree>
@@ -19714,7 +22278,7 @@
                 <a:cs typeface="Outfit"/>
                 <a:sym typeface="Outfit"/>
               </a:rPr>
-              <a:t>Pg: 17</a:t>
+              <a:t>Pg: 18</a:t>
             </a:r>
             <a:endParaRPr lang="en-US" sz="2400" dirty="0"/>
           </a:p>
@@ -20162,7 +22726,7 @@
 </p:sld>
 </file>
 
-<file path=ppt/slides/slide52.xml><?xml version="1.0" encoding="utf-8"?>
+<file path=ppt/slides/slide53.xml><?xml version="1.0" encoding="utf-8"?>
 <p:sld xmlns:a="http://schemas.openxmlformats.org/drawingml/2006/main" xmlns:p="http://schemas.openxmlformats.org/presentationml/2006/main" xmlns:r="http://schemas.openxmlformats.org/officeDocument/2006/relationships">
   <p:cSld>
     <p:spTree>
@@ -20649,7 +23213,7 @@
                 <a:cs typeface="Outfit"/>
                 <a:sym typeface="Outfit"/>
               </a:rPr>
-              <a:t>Pg: 18</a:t>
+              <a:t>Pg: 19</a:t>
             </a:r>
             <a:endParaRPr lang="en-US" sz="2400" dirty="0"/>
           </a:p>
@@ -20768,7 +23332,7 @@
                 <a:cs typeface="Outfit"/>
                 <a:sym typeface="Outfit"/>
               </a:rPr>
-              <a:t>Open orders in Argo CD.</a:t>
+              <a:t>Open orders in Argo CD at http://argocd.localhost.</a:t>
             </a:r>
             <a:endParaRPr lang="en-US" sz="2800" dirty="0"/>
           </a:p>
@@ -20952,7 +23516,7 @@
 </p:sld>
 </file>
 
-<file path=ppt/slides/slide53.xml><?xml version="1.0" encoding="utf-8"?>
+<file path=ppt/slides/slide54.xml><?xml version="1.0" encoding="utf-8"?>
 <p:sld xmlns:a="http://schemas.openxmlformats.org/drawingml/2006/main" xmlns:p="http://schemas.openxmlformats.org/presentationml/2006/main" xmlns:r="http://schemas.openxmlformats.org/officeDocument/2006/relationships">
   <p:cSld>
     <p:spTree>
@@ -21439,7 +24003,7 @@
                 <a:cs typeface="Outfit"/>
                 <a:sym typeface="Outfit"/>
               </a:rPr>
-              <a:t>Pg: 19</a:t>
+              <a:t>Pg: 20</a:t>
             </a:r>
             <a:endParaRPr lang="en-US" sz="2400" dirty="0"/>
           </a:p>
@@ -21877,7 +24441,7 @@
 </p:sld>
 </file>
 
-<file path=ppt/slides/slide54.xml><?xml version="1.0" encoding="utf-8"?>
+<file path=ppt/slides/slide55.xml><?xml version="1.0" encoding="utf-8"?>
 <p:sld xmlns:a="http://schemas.openxmlformats.org/drawingml/2006/main" xmlns:p="http://schemas.openxmlformats.org/presentationml/2006/main" xmlns:r="http://schemas.openxmlformats.org/officeDocument/2006/relationships">
   <p:cSld>
     <p:spTree>
@@ -22155,7 +24719,7 @@
 </p:sld>
 </file>
 
-<file path=ppt/slides/slide55.xml><?xml version="1.0" encoding="utf-8"?>
+<file path=ppt/slides/slide56.xml><?xml version="1.0" encoding="utf-8"?>
 <p:sld xmlns:a="http://schemas.openxmlformats.org/drawingml/2006/main" xmlns:p="http://schemas.openxmlformats.org/presentationml/2006/main" xmlns:r="http://schemas.openxmlformats.org/officeDocument/2006/relationships">
   <p:cSld>
     <p:spTree>
@@ -22596,7 +25160,7 @@
                 <a:cs typeface="Outfit"/>
                 <a:sym typeface="Outfit"/>
               </a:rPr>
-              <a:t>Pg: 21</a:t>
+              <a:t>Pg: 22</a:t>
             </a:r>
             <a:endParaRPr lang="en-US" sz="2400" dirty="0"/>
           </a:p>
@@ -23044,7 +25608,7 @@
 </p:sld>
 </file>
 
-<file path=ppt/slides/slide56.xml><?xml version="1.0" encoding="utf-8"?>
+<file path=ppt/slides/slide57.xml><?xml version="1.0" encoding="utf-8"?>
 <p:sld xmlns:a="http://schemas.openxmlformats.org/drawingml/2006/main" xmlns:p="http://schemas.openxmlformats.org/presentationml/2006/main" xmlns:r="http://schemas.openxmlformats.org/officeDocument/2006/relationships">
   <p:cSld>
     <p:spTree>
@@ -23531,7 +26095,7 @@
                 <a:cs typeface="Outfit"/>
                 <a:sym typeface="Outfit"/>
               </a:rPr>
-              <a:t>Pg: 22</a:t>
+              <a:t>Pg: 23</a:t>
             </a:r>
             <a:endParaRPr lang="en-US" sz="2400" dirty="0"/>
           </a:p>
@@ -23900,7 +26464,7 @@
 </p:sld>
 </file>
 
-<file path=ppt/slides/slide57.xml><?xml version="1.0" encoding="utf-8"?>
+<file path=ppt/slides/slide58.xml><?xml version="1.0" encoding="utf-8"?>
 <p:sld xmlns:a="http://schemas.openxmlformats.org/drawingml/2006/main" xmlns:p="http://schemas.openxmlformats.org/presentationml/2006/main" xmlns:r="http://schemas.openxmlformats.org/officeDocument/2006/relationships">
   <p:cSld>
     <p:spTree>
@@ -24387,7 +26951,7 @@
                 <a:cs typeface="Outfit"/>
                 <a:sym typeface="Outfit"/>
               </a:rPr>
-              <a:t>Pg: 23</a:t>
+              <a:t>Pg: 24</a:t>
             </a:r>
             <a:endParaRPr lang="en-US" sz="2400" dirty="0"/>
           </a:p>
@@ -24664,7 +27228,7 @@
 </p:sld>
 </file>
 
-<file path=ppt/slides/slide58.xml><?xml version="1.0" encoding="utf-8"?>
+<file path=ppt/slides/slide59.xml><?xml version="1.0" encoding="utf-8"?>
 <p:sld xmlns:a="http://schemas.openxmlformats.org/drawingml/2006/main" xmlns:p="http://schemas.openxmlformats.org/presentationml/2006/main" xmlns:r="http://schemas.openxmlformats.org/officeDocument/2006/relationships">
   <p:cSld>
     <p:spTree>
@@ -24942,7 +27506,7 @@
 </p:sld>
 </file>
 
-<file path=ppt/slides/slide59.xml><?xml version="1.0" encoding="utf-8"?>
+<file path=ppt/slides/slide60.xml><?xml version="1.0" encoding="utf-8"?>
 <p:sld xmlns:a="http://schemas.openxmlformats.org/drawingml/2006/main" xmlns:p="http://schemas.openxmlformats.org/presentationml/2006/main" xmlns:r="http://schemas.openxmlformats.org/officeDocument/2006/relationships">
   <p:cSld>
     <p:spTree>
@@ -25383,7 +27947,7 @@
                 <a:cs typeface="Outfit"/>
                 <a:sym typeface="Outfit"/>
               </a:rPr>
-              <a:t>Pg: 25</a:t>
+              <a:t>Pg: 26</a:t>
             </a:r>
             <a:endParaRPr lang="en-US" sz="2400" dirty="0"/>
           </a:p>
@@ -25761,7 +28325,7 @@
 </p:sld>
 </file>
 
-<file path=ppt/slides/slide60.xml><?xml version="1.0" encoding="utf-8"?>
+<file path=ppt/slides/slide61.xml><?xml version="1.0" encoding="utf-8"?>
 <p:sld xmlns:a="http://schemas.openxmlformats.org/drawingml/2006/main" xmlns:p="http://schemas.openxmlformats.org/presentationml/2006/main" xmlns:r="http://schemas.openxmlformats.org/officeDocument/2006/relationships">
   <p:cSld>
     <p:spTree>
@@ -26245,7 +28809,7 @@
                 <a:cs typeface="Outfit"/>
                 <a:sym typeface="Outfit"/>
               </a:rPr>
-              <a:t>Pg: 26</a:t>
+              <a:t>Pg: 27</a:t>
             </a:r>
             <a:endParaRPr lang="en-US" sz="2400" dirty="0"/>
           </a:p>
@@ -26690,7 +29254,7 @@
 </p:sld>
 </file>
 
-<file path=ppt/slides/slide61.xml><?xml version="1.0" encoding="utf-8"?>
+<file path=ppt/slides/slide62.xml><?xml version="1.0" encoding="utf-8"?>
 <p:sld xmlns:a="http://schemas.openxmlformats.org/drawingml/2006/main" xmlns:p="http://schemas.openxmlformats.org/presentationml/2006/main" xmlns:r="http://schemas.openxmlformats.org/officeDocument/2006/relationships">
   <p:cSld>
     <p:spTree>
@@ -26968,7 +29532,7 @@
 </p:sld>
 </file>
 
-<file path=ppt/slides/slide62.xml><?xml version="1.0" encoding="utf-8"?>
+<file path=ppt/slides/slide63.xml><?xml version="1.0" encoding="utf-8"?>
 <p:sld xmlns:a="http://schemas.openxmlformats.org/drawingml/2006/main" xmlns:p="http://schemas.openxmlformats.org/presentationml/2006/main" xmlns:r="http://schemas.openxmlformats.org/officeDocument/2006/relationships">
   <p:cSld>
     <p:spTree>
@@ -27167,7 +29731,7 @@
                 <a:cs typeface="Outfit"/>
                 <a:sym typeface="Outfit"/>
               </a:rPr>
-              <a:t>Pg: 28</a:t>
+              <a:t>Pg: 29</a:t>
             </a:r>
             <a:endParaRPr lang="en-US" sz="2400" dirty="0"/>
           </a:p>
@@ -29014,7 +31578,7 @@
 </p:sld>
 </file>
 
-<file path=ppt/slides/slide63.xml><?xml version="1.0" encoding="utf-8"?>
+<file path=ppt/slides/slide64.xml><?xml version="1.0" encoding="utf-8"?>
 <p:sld xmlns:a="http://schemas.openxmlformats.org/drawingml/2006/main" xmlns:p="http://schemas.openxmlformats.org/presentationml/2006/main" xmlns:r="http://schemas.openxmlformats.org/officeDocument/2006/relationships">
   <p:cSld>
     <p:spTree>
@@ -29455,7 +32019,7 @@
                 <a:cs typeface="Outfit"/>
                 <a:sym typeface="Outfit"/>
               </a:rPr>
-              <a:t>Pg: 29</a:t>
+              <a:t>Pg: 30</a:t>
             </a:r>
             <a:endParaRPr lang="en-US" sz="2400" dirty="0"/>
           </a:p>
@@ -29833,7 +32397,7 @@
 </p:sld>
 </file>
 
-<file path=ppt/slides/slide64.xml><?xml version="1.0" encoding="utf-8"?>
+<file path=ppt/slides/slide65.xml><?xml version="1.0" encoding="utf-8"?>
 <p:sld xmlns:a="http://schemas.openxmlformats.org/drawingml/2006/main" xmlns:p="http://schemas.openxmlformats.org/presentationml/2006/main" xmlns:r="http://schemas.openxmlformats.org/officeDocument/2006/relationships">
   <p:cSld>
     <p:spTree>
@@ -30320,7 +32884,7 @@
                 <a:cs typeface="Outfit"/>
                 <a:sym typeface="Outfit"/>
               </a:rPr>
-              <a:t>Pg: 30</a:t>
+              <a:t>Pg: 31</a:t>
             </a:r>
             <a:endParaRPr lang="en-US" sz="2400" dirty="0"/>
           </a:p>
@@ -30738,7 +33302,7 @@
 </p:sld>
 </file>
 
-<file path=ppt/slides/slide65.xml><?xml version="1.0" encoding="utf-8"?>
+<file path=ppt/slides/slide66.xml><?xml version="1.0" encoding="utf-8"?>
 <p:sld xmlns:a="http://schemas.openxmlformats.org/drawingml/2006/main" xmlns:p="http://schemas.openxmlformats.org/presentationml/2006/main" xmlns:r="http://schemas.openxmlformats.org/officeDocument/2006/relationships">
   <p:cSld>
     <p:spTree>
@@ -31225,7 +33789,7 @@
                 <a:cs typeface="Outfit"/>
                 <a:sym typeface="Outfit"/>
               </a:rPr>
-              <a:t>Pg: 31</a:t>
+              <a:t>Pg: 32</a:t>
             </a:r>
             <a:endParaRPr lang="en-US" sz="2400" dirty="0"/>
           </a:p>
@@ -31619,7 +34183,7 @@
 </p:sld>
 </file>
 
-<file path=ppt/slides/slide66.xml><?xml version="1.0" encoding="utf-8"?>
+<file path=ppt/slides/slide67.xml><?xml version="1.0" encoding="utf-8"?>
 <p:sld xmlns:a="http://schemas.openxmlformats.org/drawingml/2006/main" xmlns:p="http://schemas.openxmlformats.org/presentationml/2006/main" xmlns:r="http://schemas.openxmlformats.org/officeDocument/2006/relationships">
   <p:cSld>
     <p:spTree>
@@ -32106,7 +34670,7 @@
                 <a:cs typeface="Outfit"/>
                 <a:sym typeface="Outfit"/>
               </a:rPr>
-              <a:t>Pg: 32</a:t>
+              <a:t>Pg: 33</a:t>
             </a:r>
             <a:endParaRPr lang="en-US" sz="2400" dirty="0"/>
           </a:p>
@@ -32502,7 +35066,7 @@
 </p:sld>
 </file>
 
-<file path=ppt/slides/slide67.xml><?xml version="1.0" encoding="utf-8"?>
+<file path=ppt/slides/slide68.xml><?xml version="1.0" encoding="utf-8"?>
 <p:sld xmlns:a="http://schemas.openxmlformats.org/drawingml/2006/main" xmlns:p="http://schemas.openxmlformats.org/presentationml/2006/main" xmlns:r="http://schemas.openxmlformats.org/officeDocument/2006/relationships">
   <p:cSld>
     <p:spTree>
@@ -32943,7 +35507,7 @@
                 <a:cs typeface="Outfit"/>
                 <a:sym typeface="Outfit"/>
               </a:rPr>
-              <a:t>Pg: 33</a:t>
+              <a:t>Pg: 34</a:t>
             </a:r>
             <a:endParaRPr lang="en-US" sz="2400" dirty="0"/>
           </a:p>
@@ -33510,7 +36074,7 @@
 </p:sld>
 </file>
 
-<file path=ppt/slides/slide68.xml><?xml version="1.0" encoding="utf-8"?>
+<file path=ppt/slides/slide69.xml><?xml version="1.0" encoding="utf-8"?>
 <p:sld xmlns:a="http://schemas.openxmlformats.org/drawingml/2006/main" xmlns:p="http://schemas.openxmlformats.org/presentationml/2006/main" xmlns:r="http://schemas.openxmlformats.org/officeDocument/2006/relationships">
   <p:cSld>
     <p:spTree>
@@ -33997,7 +36561,7 @@
                 <a:cs typeface="Outfit"/>
                 <a:sym typeface="Outfit"/>
               </a:rPr>
-              <a:t>Pg: 34</a:t>
+              <a:t>Pg: 35</a:t>
             </a:r>
             <a:endParaRPr lang="en-US" sz="2400" dirty="0"/>
           </a:p>
@@ -34303,7 +36867,7 @@
 </p:sld>
 </file>
 
-<file path=ppt/slides/slide69.xml><?xml version="1.0" encoding="utf-8"?>
+<file path=ppt/slides/slide70.xml><?xml version="1.0" encoding="utf-8"?>
 <p:sld xmlns:a="http://schemas.openxmlformats.org/drawingml/2006/main" xmlns:p="http://schemas.openxmlformats.org/presentationml/2006/main" xmlns:r="http://schemas.openxmlformats.org/officeDocument/2006/relationships">
   <p:cSld>
     <p:spTree>
@@ -34790,7 +37354,7 @@
                 <a:cs typeface="Outfit"/>
                 <a:sym typeface="Outfit"/>
               </a:rPr>
-              <a:t>Pg: 35</a:t>
+              <a:t>Pg: 36</a:t>
             </a:r>
             <a:endParaRPr lang="en-US" sz="2400" dirty="0"/>
           </a:p>
@@ -35163,7 +37727,7 @@
 </p:sld>
 </file>
 
-<file path=ppt/slides/slide70.xml><?xml version="1.0" encoding="utf-8"?>
+<file path=ppt/slides/slide71.xml><?xml version="1.0" encoding="utf-8"?>
 <p:sld xmlns:a="http://schemas.openxmlformats.org/drawingml/2006/main" xmlns:p="http://schemas.openxmlformats.org/presentationml/2006/main" xmlns:r="http://schemas.openxmlformats.org/officeDocument/2006/relationships">
   <p:cSld>
     <p:spTree>
@@ -35441,7 +38005,7 @@
 </p:sld>
 </file>
 
-<file path=ppt/slides/slide71.xml><?xml version="1.0" encoding="utf-8"?>
+<file path=ppt/slides/slide72.xml><?xml version="1.0" encoding="utf-8"?>
 <p:sld xmlns:a="http://schemas.openxmlformats.org/drawingml/2006/main" xmlns:p="http://schemas.openxmlformats.org/presentationml/2006/main" xmlns:r="http://schemas.openxmlformats.org/officeDocument/2006/relationships">
   <p:cSld>
     <p:spTree>
@@ -35882,7 +38446,7 @@
                 <a:cs typeface="Outfit"/>
                 <a:sym typeface="Outfit"/>
               </a:rPr>
-              <a:t>Pg: 37</a:t>
+              <a:t>Pg: 38</a:t>
             </a:r>
             <a:endParaRPr lang="en-US" sz="2400" dirty="0"/>
           </a:p>
@@ -36330,7 +38894,7 @@
 </p:sld>
 </file>
 
-<file path=ppt/slides/slide72.xml><?xml version="1.0" encoding="utf-8"?>
+<file path=ppt/slides/slide73.xml><?xml version="1.0" encoding="utf-8"?>
 <p:sld xmlns:a="http://schemas.openxmlformats.org/drawingml/2006/main" xmlns:p="http://schemas.openxmlformats.org/presentationml/2006/main" xmlns:r="http://schemas.openxmlformats.org/officeDocument/2006/relationships">
   <p:cSld>
     <p:spTree>
@@ -36817,7 +39381,7 @@
                 <a:cs typeface="Outfit"/>
                 <a:sym typeface="Outfit"/>
               </a:rPr>
-              <a:t>Pg: 38</a:t>
+              <a:t>Pg: 39</a:t>
             </a:r>
             <a:endParaRPr lang="en-US" sz="2400" dirty="0"/>
           </a:p>
@@ -37211,7 +39775,7 @@
 </p:sld>
 </file>
 
-<file path=ppt/slides/slide73.xml><?xml version="1.0" encoding="utf-8"?>
+<file path=ppt/slides/slide74.xml><?xml version="1.0" encoding="utf-8"?>
 <p:sld xmlns:a="http://schemas.openxmlformats.org/drawingml/2006/main" xmlns:p="http://schemas.openxmlformats.org/presentationml/2006/main" xmlns:r="http://schemas.openxmlformats.org/officeDocument/2006/relationships">
   <p:cSld>
     <p:spTree>
@@ -37698,7 +40262,7 @@
                 <a:cs typeface="Outfit"/>
                 <a:sym typeface="Outfit"/>
               </a:rPr>
-              <a:t>Pg: 39</a:t>
+              <a:t>Pg: 40</a:t>
             </a:r>
             <a:endParaRPr lang="en-US" sz="2400" dirty="0"/>
           </a:p>
@@ -37975,7 +40539,7 @@
 </p:sld>
 </file>
 
-<file path=ppt/slides/slide74.xml><?xml version="1.0" encoding="utf-8"?>
+<file path=ppt/slides/slide75.xml><?xml version="1.0" encoding="utf-8"?>
 <p:sld xmlns:a="http://schemas.openxmlformats.org/drawingml/2006/main" xmlns:p="http://schemas.openxmlformats.org/presentationml/2006/main" xmlns:r="http://schemas.openxmlformats.org/officeDocument/2006/relationships">
   <p:cSld>
     <p:spTree>
@@ -38462,7 +41026,7 @@
                 <a:cs typeface="Outfit"/>
                 <a:sym typeface="Outfit"/>
               </a:rPr>
-              <a:t>Pg: 40</a:t>
+              <a:t>Pg: 41</a:t>
             </a:r>
             <a:endParaRPr lang="en-US" sz="2400" dirty="0"/>
           </a:p>
@@ -38802,7 +41366,7 @@
 </p:sld>
 </file>
 
-<file path=ppt/slides/slide75.xml><?xml version="1.0" encoding="utf-8"?>
+<file path=ppt/slides/slide76.xml><?xml version="1.0" encoding="utf-8"?>
 <p:sld xmlns:a="http://schemas.openxmlformats.org/drawingml/2006/main" xmlns:p="http://schemas.openxmlformats.org/presentationml/2006/main" xmlns:r="http://schemas.openxmlformats.org/officeDocument/2006/relationships">
   <p:cSld>
     <p:spTree>
@@ -39289,7 +41853,7 @@
                 <a:cs typeface="Outfit"/>
                 <a:sym typeface="Outfit"/>
               </a:rPr>
-              <a:t>Pg: 41</a:t>
+              <a:t>Pg: 42</a:t>
             </a:r>
             <a:endParaRPr lang="en-US" sz="2400" dirty="0"/>
           </a:p>
@@ -39560,7 +42124,7 @@
 </p:sld>
 </file>
 
-<file path=ppt/slides/slide76.xml><?xml version="1.0" encoding="utf-8"?>
+<file path=ppt/slides/slide77.xml><?xml version="1.0" encoding="utf-8"?>
 <p:sld xmlns:a="http://schemas.openxmlformats.org/drawingml/2006/main" xmlns:p="http://schemas.openxmlformats.org/presentationml/2006/main" xmlns:r="http://schemas.openxmlformats.org/officeDocument/2006/relationships">
   <p:cSld>
     <p:spTree>
@@ -40047,7 +42611,7 @@
                 <a:cs typeface="Outfit"/>
                 <a:sym typeface="Outfit"/>
               </a:rPr>
-              <a:t>Pg: 42</a:t>
+              <a:t>Pg: 43</a:t>
             </a:r>
             <a:endParaRPr lang="en-US" sz="2400" dirty="0"/>
           </a:p>
@@ -40393,7 +42957,7 @@
         <p:spPr>
           <a:xfrm>
             <a:off x="1024128" y="7114032"/>
-            <a:ext cx="16230600" cy="1545336"/>
+            <a:ext cx="16230600" cy="1149096"/>
           </a:xfrm>
           <a:prstGeom prst="roundRect">
             <a:avLst>
@@ -40429,7 +42993,7 @@
                 <a:cs typeface="Outfit"/>
                 <a:sym typeface="Outfit"/>
               </a:rPr>
-              <a:t>kubectl -n litellm port-forward svc/litellm 4000:4000 &amp;</a:t>
+              <a:t>set -a; source labs/00-setup/local/.litellm-admin; set +a</a:t>
             </a:r>
             <a:endParaRPr lang="en-US" sz="2400" dirty="0"/>
           </a:p>
@@ -40450,28 +43014,7 @@
                 <a:cs typeface="Outfit"/>
                 <a:sym typeface="Outfit"/>
               </a:rPr>
-              <a:t>set -a; source labs/00-setup/local/.litellm-admin; set +a</a:t>
-            </a:r>
-            <a:endParaRPr lang="en-US" sz="2400" dirty="0"/>
-          </a:p>
-          <a:p>
-            <a:pPr algn="l">
-              <a:lnSpc>
-                <a:spcPts val="3120"/>
-              </a:lnSpc>
-              <a:buNone/>
-            </a:pPr>
-            <a:r>
-              <a:rPr lang="en-US" sz="2400" dirty="0">
-                <a:solidFill>
-                  <a:srgbClr val="000000"/>
-                </a:solidFill>
-                <a:latin typeface="Outfit"/>
-                <a:ea typeface="Outfit"/>
-                <a:cs typeface="Outfit"/>
-                <a:sym typeface="Outfit"/>
-              </a:rPr>
-              <a:t>LITELLM_ADMIN_URL=http://localhost:4000 ./labs/04-guardrails-recovery/scripts/kill-switch.sh local --block-key</a:t>
+              <a:t>LITELLM_ADMIN_URL=http://litellm.localhost ./labs/04-guardrails-recovery/scripts/kill-switch.sh local --block-key</a:t>
             </a:r>
             <a:endParaRPr lang="en-US" sz="2400" dirty="0"/>
           </a:p>
@@ -40485,7 +43028,7 @@
 </p:sld>
 </file>
 
-<file path=ppt/slides/slide77.xml><?xml version="1.0" encoding="utf-8"?>
+<file path=ppt/slides/slide78.xml><?xml version="1.0" encoding="utf-8"?>
 <p:sld xmlns:a="http://schemas.openxmlformats.org/drawingml/2006/main" xmlns:p="http://schemas.openxmlformats.org/presentationml/2006/main" xmlns:r="http://schemas.openxmlformats.org/officeDocument/2006/relationships">
   <p:cSld>
     <p:spTree>
@@ -40763,7 +43306,7 @@
 </p:sld>
 </file>
 
-<file path=ppt/slides/slide78.xml><?xml version="1.0" encoding="utf-8"?>
+<file path=ppt/slides/slide79.xml><?xml version="1.0" encoding="utf-8"?>
 <p:sld xmlns:a="http://schemas.openxmlformats.org/drawingml/2006/main" xmlns:p="http://schemas.openxmlformats.org/presentationml/2006/main" xmlns:r="http://schemas.openxmlformats.org/officeDocument/2006/relationships">
   <p:cSld>
     <p:spTree>
@@ -41204,7 +43747,7 @@
                 <a:cs typeface="Outfit"/>
                 <a:sym typeface="Outfit"/>
               </a:rPr>
-              <a:t>Pg: 44</a:t>
+              <a:t>Pg: 45</a:t>
             </a:r>
             <a:endParaRPr lang="en-US" sz="2400" dirty="0"/>
           </a:p>
@@ -41582,7 +44125,7 @@
 </p:sld>
 </file>
 
-<file path=ppt/slides/slide79.xml><?xml version="1.0" encoding="utf-8"?>
+<file path=ppt/slides/slide80.xml><?xml version="1.0" encoding="utf-8"?>
 <p:sld xmlns:a="http://schemas.openxmlformats.org/drawingml/2006/main" xmlns:p="http://schemas.openxmlformats.org/presentationml/2006/main" xmlns:r="http://schemas.openxmlformats.org/officeDocument/2006/relationships">
   <p:cSld>
     <p:spTree>
@@ -42069,7 +44612,7 @@
                 <a:cs typeface="Outfit"/>
                 <a:sym typeface="Outfit"/>
               </a:rPr>
-              <a:t>Pg: 45</a:t>
+              <a:t>Pg: 46</a:t>
             </a:r>
             <a:endParaRPr lang="en-US" sz="2400" dirty="0"/>
           </a:p>
@@ -42162,7 +44705,7 @@
                 <a:cs typeface="Outfit"/>
                 <a:sym typeface="Outfit"/>
               </a:rPr>
-              <a:t>Port-forward Langfuse and read the login password from its Secret:</a:t>
+              <a:t>Read the login password from its Secret:</a:t>
             </a:r>
             <a:endParaRPr lang="en-US" sz="2800" dirty="0"/>
           </a:p>
@@ -42177,7 +44720,7 @@
         <p:spPr>
           <a:xfrm>
             <a:off x="1024128" y="3286760"/>
-            <a:ext cx="16230600" cy="1132586"/>
+            <a:ext cx="16230600" cy="744601"/>
           </a:xfrm>
           <a:prstGeom prst="roundRect">
             <a:avLst>
@@ -42213,27 +44756,6 @@
                 <a:cs typeface="Outfit"/>
                 <a:sym typeface="Outfit"/>
               </a:rPr>
-              <a:t>kubectl -n langfuse port-forward svc/langfuse-web 3000:3000</a:t>
-            </a:r>
-            <a:endParaRPr lang="en-US" sz="2350" dirty="0"/>
-          </a:p>
-          <a:p>
-            <a:pPr algn="l">
-              <a:lnSpc>
-                <a:spcPts val="3055"/>
-              </a:lnSpc>
-              <a:buNone/>
-            </a:pPr>
-            <a:r>
-              <a:rPr lang="en-US" sz="2350" dirty="0">
-                <a:solidFill>
-                  <a:srgbClr val="000000"/>
-                </a:solidFill>
-                <a:latin typeface="Outfit"/>
-                <a:ea typeface="Outfit"/>
-                <a:cs typeface="Outfit"/>
-                <a:sym typeface="Outfit"/>
-              </a:rPr>
               <a:t>kubectl -n langfuse get secret langfuse-secrets -o jsonpath='{.data.LANGFUSE_INIT_USER_PASSWORD}' | base64 -d</a:t>
             </a:r>
             <a:endParaRPr lang="en-US" sz="2350" dirty="0"/>
@@ -42248,7 +44770,7 @@
         </p:nvSpPr>
         <p:spPr>
           <a:xfrm>
-            <a:off x="1024128" y="4693666"/>
+            <a:off x="1024128" y="4305681"/>
             <a:ext cx="16230600" cy="2570480"/>
           </a:xfrm>
           <a:prstGeom prst="rect">
@@ -42281,7 +44803,7 @@
                 <a:cs typeface="Outfit"/>
                 <a:sym typeface="Outfit"/>
               </a:rPr>
-              <a:t>Log in at http://localhost:3000 as workshop@example.com and open the workshop project.</a:t>
+              <a:t>Log in at http://langfuse.localhost as workshop@example.com and open the workshop project.</a:t>
             </a:r>
             <a:endParaRPr lang="en-US" sz="2800" dirty="0"/>
           </a:p>
@@ -42370,7 +44892,7 @@
 </p:sld>
 </file>
 
-<file path=ppt/slides/slide80.xml><?xml version="1.0" encoding="utf-8"?>
+<file path=ppt/slides/slide81.xml><?xml version="1.0" encoding="utf-8"?>
 <p:sld xmlns:a="http://schemas.openxmlformats.org/drawingml/2006/main" xmlns:p="http://schemas.openxmlformats.org/presentationml/2006/main" xmlns:r="http://schemas.openxmlformats.org/officeDocument/2006/relationships">
   <p:cSld>
     <p:spTree>
@@ -42648,7 +45170,7 @@
 </p:sld>
 </file>
 
-<file path=ppt/slides/slide81.xml><?xml version="1.0" encoding="utf-8"?>
+<file path=ppt/slides/slide82.xml><?xml version="1.0" encoding="utf-8"?>
 <p:sld xmlns:a="http://schemas.openxmlformats.org/drawingml/2006/main" xmlns:p="http://schemas.openxmlformats.org/presentationml/2006/main" xmlns:r="http://schemas.openxmlformats.org/officeDocument/2006/relationships">
   <p:cSld>
     <p:spTree>
@@ -42825,7 +45347,7 @@
                 <a:cs typeface="Outfit"/>
                 <a:sym typeface="Outfit"/>
               </a:rPr>
-              <a:t>Pg: 47</a:t>
+              <a:t>Pg: 48</a:t>
             </a:r>
             <a:endParaRPr lang="en-US" sz="2400" dirty="0"/>
           </a:p>
@@ -44253,7 +46775,7 @@
 </p:sld>
 </file>
 
-<file path=ppt/slides/slide82.xml><?xml version="1.0" encoding="utf-8"?>
+<file path=ppt/slides/slide83.xml><?xml version="1.0" encoding="utf-8"?>
 <p:sld xmlns:a="http://schemas.openxmlformats.org/drawingml/2006/main" xmlns:p="http://schemas.openxmlformats.org/presentationml/2006/main" xmlns:r="http://schemas.openxmlformats.org/officeDocument/2006/relationships">
   <p:cSld>
     <p:bg>
@@ -44718,7 +47240,7 @@
 </p:sld>
 </file>
 
-<file path=ppt/slides/slide83.xml><?xml version="1.0" encoding="utf-8"?>
+<file path=ppt/slides/slide84.xml><?xml version="1.0" encoding="utf-8"?>
 <p:sld xmlns:a="http://schemas.openxmlformats.org/drawingml/2006/main" xmlns:p="http://schemas.openxmlformats.org/presentationml/2006/main" xmlns:r="http://schemas.openxmlformats.org/officeDocument/2006/relationships">
   <p:cSld>
     <p:spTree>
@@ -44895,7 +47417,7 @@
                 <a:cs typeface="Outfit"/>
                 <a:sym typeface="Outfit"/>
               </a:rPr>
-              <a:t>Pg: 49</a:t>
+              <a:t>Pg: 50</a:t>
             </a:r>
             <a:endParaRPr lang="en-US" sz="2400" dirty="0"/>
           </a:p>
@@ -46239,7 +48761,7 @@
 </p:sld>
 </file>
 
-<file path=ppt/slides/slide84.xml><?xml version="1.0" encoding="utf-8"?>
+<file path=ppt/slides/slide85.xml><?xml version="1.0" encoding="utf-8"?>
 <p:sld xmlns:a="http://schemas.openxmlformats.org/drawingml/2006/main" xmlns:p="http://schemas.openxmlformats.org/presentationml/2006/main" xmlns:r="http://schemas.openxmlformats.org/officeDocument/2006/relationships">
   <p:cSld>
     <p:spTree>

</xml_diff>

<commit_message>
docs(slides): say agent harness instead of Cursor (#14)
</commit_message>
<xml_diff>
--- a/slides/agentic-idp-workshop.pptx
+++ b/slides/agentic-idp-workshop.pptx
@@ -9950,7 +9950,7 @@
                 <a:cs typeface="Outfit"/>
                 <a:sym typeface="Outfit"/>
               </a:rPr>
-              <a:t>Or let Cursor do it: ask it to follow labs/02-knowledge-base/kb/guides/onboarding.md.</a:t>
+              <a:t>Or let an agent harness do it: ask it to follow labs/02-knowledge-base/kb/guides/onboarding.md.</a:t>
             </a:r>
             <a:endParaRPr lang="en-US" sz="2600" dirty="0"/>
           </a:p>
@@ -27044,7 +27044,7 @@
                 <a:cs typeface="Outfit"/>
                 <a:sym typeface="Outfit"/>
               </a:rPr>
-              <a:t>Open Cursor in your fork and ask, in a new chat:</a:t>
+              <a:t>Open an agent harness in your fork and ask, in a new chat:</a:t>
             </a:r>
             <a:endParaRPr lang="en-US" sz="2800" dirty="0"/>
           </a:p>
@@ -33882,7 +33882,7 @@
                 <a:cs typeface="Outfit"/>
                 <a:sym typeface="Outfit"/>
               </a:rPr>
-              <a:t>Step 2. Follow kb/guides/deploy-an-agent.md, or ask Cursor to. Either way, the result is:</a:t>
+              <a:t>Step 2. Follow kb/guides/deploy-an-agent.md, or ask an agent harness to. Either way, the result is:</a:t>
             </a:r>
             <a:endParaRPr lang="en-US" sz="2800" dirty="0"/>
           </a:p>
@@ -48433,7 +48433,7 @@
                           <a:cs typeface="Outfit"/>
                           <a:sym typeface="Outfit"/>
                         </a:rPr>
-                        <a:t>Let Cursor rebuild the environment for you</a:t>
+                        <a:t>Let an agent harness rebuild the environment for you</a:t>
                       </a:r>
                       <a:endParaRPr lang="en-US" sz="2400" dirty="0"/>
                     </a:p>

</xml_diff>

<commit_message>
docs: fix gaps found in a full workshop run (#16)
</commit_message>
<xml_diff>
--- a/slides/agentic-idp-workshop.pptx
+++ b/slides/agentic-idp-workshop.pptx
@@ -12297,7 +12297,7 @@
                 <a:cs typeface="Outfit"/>
                 <a:sym typeface="Outfit"/>
               </a:rPr>
-              <a:t>Every UI is on port 80: http://argocd.localhost, http://langfuse.localhost, http://litellm.localhost, and http://orders.localhost. Log in to Argo CD as admin:</a:t>
+              <a:t>Every UI is on port 80: http://argocd.localhost, http://langfuse.localhost, http://litellm.localhost, and http://orders.localhost/orders. Log in to Argo CD as admin:</a:t>
             </a:r>
             <a:endParaRPr lang="en-US" sz="2800" dirty="0"/>
           </a:p>
@@ -24278,7 +24278,7 @@
                 <a:cs typeface="Outfit"/>
                 <a:sym typeface="Outfit"/>
               </a:rPr>
-              <a:t>The check fails with an error an agent can act on, and main blocks the merge:</a:t>
+              <a:t>validate fails with an error an agent can act on:</a:t>
             </a:r>
             <a:endParaRPr lang="en-US" sz="2600" dirty="0"/>
           </a:p>
@@ -24376,7 +24376,7 @@
                 <a:cs typeface="Outfit"/>
                 <a:sym typeface="Outfit"/>
               </a:rPr>
-              <a:t>Close the PR and go back to main:</a:t>
+              <a:t>freshness and verify fail too (the catalog lists the tag). main blocks the merge. Close the PR:</a:t>
             </a:r>
             <a:endParaRPr lang="en-US" sz="2600" dirty="0"/>
           </a:p>
@@ -44828,7 +44828,7 @@
                 <a:cs typeface="Outfit"/>
                 <a:sym typeface="Outfit"/>
               </a:rPr>
-              <a:t>Find the trace for the triage you watched in Lab 3.</a:t>
+              <a:t>Each model call is one trace. Find the traces from your Lab 3 triage by time.</a:t>
             </a:r>
             <a:endParaRPr lang="en-US" sz="2800" dirty="0"/>
           </a:p>

</xml_diff>